<commit_message>
docs: update presentation slides for SPME Fuzzy-DCNN oral exam
</commit_message>
<xml_diff>
--- a/docs/presentazione_SPME_Fuzzy_DCNN.pptx
+++ b/docs/presentazione_SPME_Fuzzy_DCNN.pptx
@@ -189,6 +189,22 @@
             <ac:graphicFrameMk id="13" creationId="{00000000-0000-0000-0000-000000000000}"/>
           </ac:graphicFrameMkLst>
         </pc:graphicFrameChg>
+      </pc:sldChg>
+    </pc:docChg>
+  </pc:docChgLst>
+  <pc:docChgLst>
+    <pc:chgData name="FABRIZIO APUZZO" userId="S::fab.apuzzo@studenti.unina.it::d2e4b4f4-4f4c-4d22-be90-e12d8f7aad87" providerId="AD" clId="Web-{DF1A3324-A0F6-E9A8-208E-9003A0BBC7A9}"/>
+    <pc:docChg chg="modSld">
+      <pc:chgData name="FABRIZIO APUZZO" userId="S::fab.apuzzo@studenti.unina.it::d2e4b4f4-4f4c-4d22-be90-e12d8f7aad87" providerId="AD" clId="Web-{DF1A3324-A0F6-E9A8-208E-9003A0BBC7A9}" dt="2026-10-06T15:05:51.368" v="7"/>
+      <pc:docMkLst>
+        <pc:docMk/>
+      </pc:docMkLst>
+      <pc:sldChg chg="modSp">
+        <pc:chgData name="FABRIZIO APUZZO" userId="S::fab.apuzzo@studenti.unina.it::d2e4b4f4-4f4c-4d22-be90-e12d8f7aad87" providerId="AD" clId="Web-{DF1A3324-A0F6-E9A8-208E-9003A0BBC7A9}" dt="2026-10-06T15:05:51.368" v="7"/>
+        <pc:sldMkLst>
+          <pc:docMk/>
+          <pc:sldMk cId="0" sldId="269"/>
+        </pc:sldMkLst>
       </pc:sldChg>
     </pc:docChg>
   </pc:docChgLst>
@@ -409,224 +425,6 @@
             <ac:spMk id="56" creationId="{162495C1-8554-8E67-4C0D-7BFB9FA9C0D8}"/>
           </ac:spMkLst>
         </pc:spChg>
-      </pc:sldChg>
-    </pc:docChg>
-  </pc:docChgLst>
-  <pc:docChgLst>
-    <pc:chgData name="FABRIZIO APUZZO" userId="S::fab.apuzzo@studenti.unina.it::d2e4b4f4-4f4c-4d22-be90-e12d8f7aad87" providerId="AD" clId="Web-{45BAA69B-9353-1306-EC09-7B692948B43F}"/>
-    <pc:docChg chg="modSld">
-      <pc:chgData name="FABRIZIO APUZZO" userId="S::fab.apuzzo@studenti.unina.it::d2e4b4f4-4f4c-4d22-be90-e12d8f7aad87" providerId="AD" clId="Web-{45BAA69B-9353-1306-EC09-7B692948B43F}" dt="2026-10-05T14:52:59.092" v="527" actId="1076"/>
-      <pc:docMkLst>
-        <pc:docMk/>
-      </pc:docMkLst>
-      <pc:sldChg chg="modSp">
-        <pc:chgData name="FABRIZIO APUZZO" userId="S::fab.apuzzo@studenti.unina.it::d2e4b4f4-4f4c-4d22-be90-e12d8f7aad87" providerId="AD" clId="Web-{45BAA69B-9353-1306-EC09-7B692948B43F}" dt="2026-10-05T13:25:03.218" v="1" actId="20577"/>
-        <pc:sldMkLst>
-          <pc:docMk/>
-          <pc:sldMk cId="0" sldId="256"/>
-        </pc:sldMkLst>
-        <pc:spChg chg="mod">
-          <ac:chgData name="FABRIZIO APUZZO" userId="S::fab.apuzzo@studenti.unina.it::d2e4b4f4-4f4c-4d22-be90-e12d8f7aad87" providerId="AD" clId="Web-{45BAA69B-9353-1306-EC09-7B692948B43F}" dt="2026-10-05T13:25:03.218" v="1" actId="20577"/>
-          <ac:spMkLst>
-            <pc:docMk/>
-            <pc:sldMk cId="0" sldId="256"/>
-            <ac:spMk id="4" creationId="{00000000-0000-0000-0000-000000000000}"/>
-          </ac:spMkLst>
-        </pc:spChg>
-      </pc:sldChg>
-      <pc:sldChg chg="modSp">
-        <pc:chgData name="FABRIZIO APUZZO" userId="S::fab.apuzzo@studenti.unina.it::d2e4b4f4-4f4c-4d22-be90-e12d8f7aad87" providerId="AD" clId="Web-{45BAA69B-9353-1306-EC09-7B692948B43F}" dt="2026-10-05T14:00:29.412" v="62" actId="20577"/>
-        <pc:sldMkLst>
-          <pc:docMk/>
-          <pc:sldMk cId="0" sldId="257"/>
-        </pc:sldMkLst>
-        <pc:spChg chg="mod">
-          <ac:chgData name="FABRIZIO APUZZO" userId="S::fab.apuzzo@studenti.unina.it::d2e4b4f4-4f4c-4d22-be90-e12d8f7aad87" providerId="AD" clId="Web-{45BAA69B-9353-1306-EC09-7B692948B43F}" dt="2026-10-05T14:00:29.412" v="62" actId="20577"/>
-          <ac:spMkLst>
-            <pc:docMk/>
-            <pc:sldMk cId="0" sldId="257"/>
-            <ac:spMk id="2" creationId="{00000000-0000-0000-0000-000000000000}"/>
-          </ac:spMkLst>
-        </pc:spChg>
-        <pc:spChg chg="mod">
-          <ac:chgData name="FABRIZIO APUZZO" userId="S::fab.apuzzo@studenti.unina.it::d2e4b4f4-4f4c-4d22-be90-e12d8f7aad87" providerId="AD" clId="Web-{45BAA69B-9353-1306-EC09-7B692948B43F}" dt="2026-10-05T13:28:00.529" v="4" actId="20577"/>
-          <ac:spMkLst>
-            <pc:docMk/>
-            <pc:sldMk cId="0" sldId="257"/>
-            <ac:spMk id="3" creationId="{00000000-0000-0000-0000-000000000000}"/>
-          </ac:spMkLst>
-        </pc:spChg>
-        <pc:spChg chg="mod">
-          <ac:chgData name="FABRIZIO APUZZO" userId="S::fab.apuzzo@studenti.unina.it::d2e4b4f4-4f4c-4d22-be90-e12d8f7aad87" providerId="AD" clId="Web-{45BAA69B-9353-1306-EC09-7B692948B43F}" dt="2026-10-05T13:30:18.868" v="6" actId="20577"/>
-          <ac:spMkLst>
-            <pc:docMk/>
-            <pc:sldMk cId="0" sldId="257"/>
-            <ac:spMk id="18" creationId="{00000000-0000-0000-0000-000000000000}"/>
-          </ac:spMkLst>
-        </pc:spChg>
-      </pc:sldChg>
-      <pc:sldChg chg="modSp">
-        <pc:chgData name="FABRIZIO APUZZO" userId="S::fab.apuzzo@studenti.unina.it::d2e4b4f4-4f4c-4d22-be90-e12d8f7aad87" providerId="AD" clId="Web-{45BAA69B-9353-1306-EC09-7B692948B43F}" dt="2026-10-05T13:38:06.201" v="8" actId="20577"/>
-        <pc:sldMkLst>
-          <pc:docMk/>
-          <pc:sldMk cId="0" sldId="258"/>
-        </pc:sldMkLst>
-        <pc:spChg chg="mod">
-          <ac:chgData name="FABRIZIO APUZZO" userId="S::fab.apuzzo@studenti.unina.it::d2e4b4f4-4f4c-4d22-be90-e12d8f7aad87" providerId="AD" clId="Web-{45BAA69B-9353-1306-EC09-7B692948B43F}" dt="2026-10-05T13:38:06.201" v="8" actId="20577"/>
-          <ac:spMkLst>
-            <pc:docMk/>
-            <pc:sldMk cId="0" sldId="258"/>
-            <ac:spMk id="42" creationId="{00000000-0000-0000-0000-000000000000}"/>
-          </ac:spMkLst>
-        </pc:spChg>
-      </pc:sldChg>
-      <pc:sldChg chg="modSp">
-        <pc:chgData name="FABRIZIO APUZZO" userId="S::fab.apuzzo@studenti.unina.it::d2e4b4f4-4f4c-4d22-be90-e12d8f7aad87" providerId="AD" clId="Web-{45BAA69B-9353-1306-EC09-7B692948B43F}" dt="2026-10-05T13:59:01.343" v="47" actId="20577"/>
-        <pc:sldMkLst>
-          <pc:docMk/>
-          <pc:sldMk cId="0" sldId="261"/>
-        </pc:sldMkLst>
-        <pc:spChg chg="mod">
-          <ac:chgData name="FABRIZIO APUZZO" userId="S::fab.apuzzo@studenti.unina.it::d2e4b4f4-4f4c-4d22-be90-e12d8f7aad87" providerId="AD" clId="Web-{45BAA69B-9353-1306-EC09-7B692948B43F}" dt="2026-10-05T13:57:16.663" v="28" actId="20577"/>
-          <ac:spMkLst>
-            <pc:docMk/>
-            <pc:sldMk cId="0" sldId="261"/>
-            <ac:spMk id="7" creationId="{00000000-0000-0000-0000-000000000000}"/>
-          </ac:spMkLst>
-        </pc:spChg>
-        <pc:spChg chg="mod">
-          <ac:chgData name="FABRIZIO APUZZO" userId="S::fab.apuzzo@studenti.unina.it::d2e4b4f4-4f4c-4d22-be90-e12d8f7aad87" providerId="AD" clId="Web-{45BAA69B-9353-1306-EC09-7B692948B43F}" dt="2026-10-05T13:58:17.746" v="45" actId="20577"/>
-          <ac:spMkLst>
-            <pc:docMk/>
-            <pc:sldMk cId="0" sldId="261"/>
-            <ac:spMk id="11" creationId="{00000000-0000-0000-0000-000000000000}"/>
-          </ac:spMkLst>
-        </pc:spChg>
-        <pc:spChg chg="mod">
-          <ac:chgData name="FABRIZIO APUZZO" userId="S::fab.apuzzo@studenti.unina.it::d2e4b4f4-4f4c-4d22-be90-e12d8f7aad87" providerId="AD" clId="Web-{45BAA69B-9353-1306-EC09-7B692948B43F}" dt="2026-10-05T13:59:01.343" v="47" actId="20577"/>
-          <ac:spMkLst>
-            <pc:docMk/>
-            <pc:sldMk cId="0" sldId="261"/>
-            <ac:spMk id="13" creationId="{00000000-0000-0000-0000-000000000000}"/>
-          </ac:spMkLst>
-        </pc:spChg>
-      </pc:sldChg>
-      <pc:sldChg chg="modSp">
-        <pc:chgData name="FABRIZIO APUZZO" userId="S::fab.apuzzo@studenti.unina.it::d2e4b4f4-4f4c-4d22-be90-e12d8f7aad87" providerId="AD" clId="Web-{45BAA69B-9353-1306-EC09-7B692948B43F}" dt="2026-10-05T14:00:54.586" v="64" actId="20577"/>
-        <pc:sldMkLst>
-          <pc:docMk/>
-          <pc:sldMk cId="0" sldId="262"/>
-        </pc:sldMkLst>
-        <pc:spChg chg="mod">
-          <ac:chgData name="FABRIZIO APUZZO" userId="S::fab.apuzzo@studenti.unina.it::d2e4b4f4-4f4c-4d22-be90-e12d8f7aad87" providerId="AD" clId="Web-{45BAA69B-9353-1306-EC09-7B692948B43F}" dt="2026-10-05T14:00:22.177" v="60" actId="20577"/>
-          <ac:spMkLst>
-            <pc:docMk/>
-            <pc:sldMk cId="0" sldId="262"/>
-            <ac:spMk id="2" creationId="{00000000-0000-0000-0000-000000000000}"/>
-          </ac:spMkLst>
-        </pc:spChg>
-        <pc:spChg chg="mod">
-          <ac:chgData name="FABRIZIO APUZZO" userId="S::fab.apuzzo@studenti.unina.it::d2e4b4f4-4f4c-4d22-be90-e12d8f7aad87" providerId="AD" clId="Web-{45BAA69B-9353-1306-EC09-7B692948B43F}" dt="2026-10-05T14:00:54.586" v="64" actId="20577"/>
-          <ac:spMkLst>
-            <pc:docMk/>
-            <pc:sldMk cId="0" sldId="262"/>
-            <ac:spMk id="3" creationId="{00000000-0000-0000-0000-000000000000}"/>
-          </ac:spMkLst>
-        </pc:spChg>
-        <pc:spChg chg="mod">
-          <ac:chgData name="FABRIZIO APUZZO" userId="S::fab.apuzzo@studenti.unina.it::d2e4b4f4-4f4c-4d22-be90-e12d8f7aad87" providerId="AD" clId="Web-{45BAA69B-9353-1306-EC09-7B692948B43F}" dt="2026-10-05T13:59:35.502" v="50" actId="20577"/>
-          <ac:spMkLst>
-            <pc:docMk/>
-            <pc:sldMk cId="0" sldId="262"/>
-            <ac:spMk id="21" creationId="{00000000-0000-0000-0000-000000000000}"/>
-          </ac:spMkLst>
-        </pc:spChg>
-        <pc:spChg chg="mod">
-          <ac:chgData name="FABRIZIO APUZZO" userId="S::fab.apuzzo@studenti.unina.it::d2e4b4f4-4f4c-4d22-be90-e12d8f7aad87" providerId="AD" clId="Web-{45BAA69B-9353-1306-EC09-7B692948B43F}" dt="2026-10-05T13:59:57.957" v="52" actId="20577"/>
-          <ac:spMkLst>
-            <pc:docMk/>
-            <pc:sldMk cId="0" sldId="262"/>
-            <ac:spMk id="29" creationId="{00000000-0000-0000-0000-000000000000}"/>
-          </ac:spMkLst>
-        </pc:spChg>
-      </pc:sldChg>
-      <pc:sldChg chg="modSp">
-        <pc:chgData name="FABRIZIO APUZZO" userId="S::fab.apuzzo@studenti.unina.it::d2e4b4f4-4f4c-4d22-be90-e12d8f7aad87" providerId="AD" clId="Web-{45BAA69B-9353-1306-EC09-7B692948B43F}" dt="2026-10-05T14:52:59.092" v="527" actId="1076"/>
-        <pc:sldMkLst>
-          <pc:docMk/>
-          <pc:sldMk cId="0" sldId="263"/>
-        </pc:sldMkLst>
-        <pc:spChg chg="mod">
-          <ac:chgData name="FABRIZIO APUZZO" userId="S::fab.apuzzo@studenti.unina.it::d2e4b4f4-4f4c-4d22-be90-e12d8f7aad87" providerId="AD" clId="Web-{45BAA69B-9353-1306-EC09-7B692948B43F}" dt="2026-10-05T14:52:59.092" v="527" actId="1076"/>
-          <ac:spMkLst>
-            <pc:docMk/>
-            <pc:sldMk cId="0" sldId="263"/>
-            <ac:spMk id="2" creationId="{00000000-0000-0000-0000-000000000000}"/>
-          </ac:spMkLst>
-        </pc:spChg>
-        <pc:spChg chg="mod">
-          <ac:chgData name="FABRIZIO APUZZO" userId="S::fab.apuzzo@studenti.unina.it::d2e4b4f4-4f4c-4d22-be90-e12d8f7aad87" providerId="AD" clId="Web-{45BAA69B-9353-1306-EC09-7B692948B43F}" dt="2026-10-05T14:06:08.657" v="89" actId="20577"/>
-          <ac:spMkLst>
-            <pc:docMk/>
-            <pc:sldMk cId="0" sldId="263"/>
-            <ac:spMk id="3" creationId="{00000000-0000-0000-0000-000000000000}"/>
-          </ac:spMkLst>
-        </pc:spChg>
-        <pc:spChg chg="mod">
-          <ac:chgData name="FABRIZIO APUZZO" userId="S::fab.apuzzo@studenti.unina.it::d2e4b4f4-4f4c-4d22-be90-e12d8f7aad87" providerId="AD" clId="Web-{45BAA69B-9353-1306-EC09-7B692948B43F}" dt="2026-10-05T14:16:07.734" v="504" actId="20577"/>
-          <ac:spMkLst>
-            <pc:docMk/>
-            <pc:sldMk cId="0" sldId="263"/>
-            <ac:spMk id="10" creationId="{00000000-0000-0000-0000-000000000000}"/>
-          </ac:spMkLst>
-        </pc:spChg>
-        <pc:spChg chg="mod">
-          <ac:chgData name="FABRIZIO APUZZO" userId="S::fab.apuzzo@studenti.unina.it::d2e4b4f4-4f4c-4d22-be90-e12d8f7aad87" providerId="AD" clId="Web-{45BAA69B-9353-1306-EC09-7B692948B43F}" dt="2026-10-05T14:52:58.201" v="526" actId="20577"/>
-          <ac:spMkLst>
-            <pc:docMk/>
-            <pc:sldMk cId="0" sldId="263"/>
-            <ac:spMk id="14" creationId="{00000000-0000-0000-0000-000000000000}"/>
-          </ac:spMkLst>
-        </pc:spChg>
-        <pc:spChg chg="mod">
-          <ac:chgData name="FABRIZIO APUZZO" userId="S::fab.apuzzo@studenti.unina.it::d2e4b4f4-4f4c-4d22-be90-e12d8f7aad87" providerId="AD" clId="Web-{45BAA69B-9353-1306-EC09-7B692948B43F}" dt="2026-10-05T14:21:24.087" v="507" actId="20577"/>
-          <ac:spMkLst>
-            <pc:docMk/>
-            <pc:sldMk cId="0" sldId="263"/>
-            <ac:spMk id="22" creationId="{00000000-0000-0000-0000-000000000000}"/>
-          </ac:spMkLst>
-        </pc:spChg>
-      </pc:sldChg>
-      <pc:sldChg chg="modSp">
-        <pc:chgData name="FABRIZIO APUZZO" userId="S::fab.apuzzo@studenti.unina.it::d2e4b4f4-4f4c-4d22-be90-e12d8f7aad87" providerId="AD" clId="Web-{45BAA69B-9353-1306-EC09-7B692948B43F}" dt="2026-10-05T14:46:22.249" v="509" actId="20577"/>
-        <pc:sldMkLst>
-          <pc:docMk/>
-          <pc:sldMk cId="0" sldId="265"/>
-        </pc:sldMkLst>
-        <pc:spChg chg="mod">
-          <ac:chgData name="FABRIZIO APUZZO" userId="S::fab.apuzzo@studenti.unina.it::d2e4b4f4-4f4c-4d22-be90-e12d8f7aad87" providerId="AD" clId="Web-{45BAA69B-9353-1306-EC09-7B692948B43F}" dt="2026-10-05T14:46:22.249" v="509" actId="20577"/>
-          <ac:spMkLst>
-            <pc:docMk/>
-            <pc:sldMk cId="0" sldId="265"/>
-            <ac:spMk id="10" creationId="{00000000-0000-0000-0000-000000000000}"/>
-          </ac:spMkLst>
-        </pc:spChg>
-      </pc:sldChg>
-    </pc:docChg>
-  </pc:docChgLst>
-  <pc:docChgLst>
-    <pc:chgData name="FABRIZIO APUZZO" userId="S::fab.apuzzo@studenti.unina.it::d2e4b4f4-4f4c-4d22-be90-e12d8f7aad87" providerId="AD" clId="Web-{DF1A3324-A0F6-E9A8-208E-9003A0BBC7A9}"/>
-    <pc:docChg chg="modSld">
-      <pc:chgData name="FABRIZIO APUZZO" userId="S::fab.apuzzo@studenti.unina.it::d2e4b4f4-4f4c-4d22-be90-e12d8f7aad87" providerId="AD" clId="Web-{DF1A3324-A0F6-E9A8-208E-9003A0BBC7A9}" dt="2026-10-06T15:05:51.368" v="7"/>
-      <pc:docMkLst>
-        <pc:docMk/>
-      </pc:docMkLst>
-      <pc:sldChg chg="modSp">
-        <pc:chgData name="FABRIZIO APUZZO" userId="S::fab.apuzzo@studenti.unina.it::d2e4b4f4-4f4c-4d22-be90-e12d8f7aad87" providerId="AD" clId="Web-{DF1A3324-A0F6-E9A8-208E-9003A0BBC7A9}" dt="2026-10-06T15:05:51.368" v="7"/>
-        <pc:sldMkLst>
-          <pc:docMk/>
-          <pc:sldMk cId="0" sldId="269"/>
-        </pc:sldMkLst>
       </pc:sldChg>
     </pc:docChg>
   </pc:docChgLst>
@@ -1146,6 +944,208 @@
       </pc:sldChg>
     </pc:docChg>
   </pc:docChgLst>
+  <pc:docChgLst>
+    <pc:chgData name="FABRIZIO APUZZO" userId="S::fab.apuzzo@studenti.unina.it::d2e4b4f4-4f4c-4d22-be90-e12d8f7aad87" providerId="AD" clId="Web-{45BAA69B-9353-1306-EC09-7B692948B43F}"/>
+    <pc:docChg chg="modSld">
+      <pc:chgData name="FABRIZIO APUZZO" userId="S::fab.apuzzo@studenti.unina.it::d2e4b4f4-4f4c-4d22-be90-e12d8f7aad87" providerId="AD" clId="Web-{45BAA69B-9353-1306-EC09-7B692948B43F}" dt="2026-10-05T14:52:59.092" v="527" actId="1076"/>
+      <pc:docMkLst>
+        <pc:docMk/>
+      </pc:docMkLst>
+      <pc:sldChg chg="modSp">
+        <pc:chgData name="FABRIZIO APUZZO" userId="S::fab.apuzzo@studenti.unina.it::d2e4b4f4-4f4c-4d22-be90-e12d8f7aad87" providerId="AD" clId="Web-{45BAA69B-9353-1306-EC09-7B692948B43F}" dt="2026-10-05T13:25:03.218" v="1" actId="20577"/>
+        <pc:sldMkLst>
+          <pc:docMk/>
+          <pc:sldMk cId="0" sldId="256"/>
+        </pc:sldMkLst>
+        <pc:spChg chg="mod">
+          <ac:chgData name="FABRIZIO APUZZO" userId="S::fab.apuzzo@studenti.unina.it::d2e4b4f4-4f4c-4d22-be90-e12d8f7aad87" providerId="AD" clId="Web-{45BAA69B-9353-1306-EC09-7B692948B43F}" dt="2026-10-05T13:25:03.218" v="1" actId="20577"/>
+          <ac:spMkLst>
+            <pc:docMk/>
+            <pc:sldMk cId="0" sldId="256"/>
+            <ac:spMk id="4" creationId="{00000000-0000-0000-0000-000000000000}"/>
+          </ac:spMkLst>
+        </pc:spChg>
+      </pc:sldChg>
+      <pc:sldChg chg="modSp">
+        <pc:chgData name="FABRIZIO APUZZO" userId="S::fab.apuzzo@studenti.unina.it::d2e4b4f4-4f4c-4d22-be90-e12d8f7aad87" providerId="AD" clId="Web-{45BAA69B-9353-1306-EC09-7B692948B43F}" dt="2026-10-05T14:00:29.412" v="62" actId="20577"/>
+        <pc:sldMkLst>
+          <pc:docMk/>
+          <pc:sldMk cId="0" sldId="257"/>
+        </pc:sldMkLst>
+        <pc:spChg chg="mod">
+          <ac:chgData name="FABRIZIO APUZZO" userId="S::fab.apuzzo@studenti.unina.it::d2e4b4f4-4f4c-4d22-be90-e12d8f7aad87" providerId="AD" clId="Web-{45BAA69B-9353-1306-EC09-7B692948B43F}" dt="2026-10-05T14:00:29.412" v="62" actId="20577"/>
+          <ac:spMkLst>
+            <pc:docMk/>
+            <pc:sldMk cId="0" sldId="257"/>
+            <ac:spMk id="2" creationId="{00000000-0000-0000-0000-000000000000}"/>
+          </ac:spMkLst>
+        </pc:spChg>
+        <pc:spChg chg="mod">
+          <ac:chgData name="FABRIZIO APUZZO" userId="S::fab.apuzzo@studenti.unina.it::d2e4b4f4-4f4c-4d22-be90-e12d8f7aad87" providerId="AD" clId="Web-{45BAA69B-9353-1306-EC09-7B692948B43F}" dt="2026-10-05T13:28:00.529" v="4" actId="20577"/>
+          <ac:spMkLst>
+            <pc:docMk/>
+            <pc:sldMk cId="0" sldId="257"/>
+            <ac:spMk id="3" creationId="{00000000-0000-0000-0000-000000000000}"/>
+          </ac:spMkLst>
+        </pc:spChg>
+        <pc:spChg chg="mod">
+          <ac:chgData name="FABRIZIO APUZZO" userId="S::fab.apuzzo@studenti.unina.it::d2e4b4f4-4f4c-4d22-be90-e12d8f7aad87" providerId="AD" clId="Web-{45BAA69B-9353-1306-EC09-7B692948B43F}" dt="2026-10-05T13:30:18.868" v="6" actId="20577"/>
+          <ac:spMkLst>
+            <pc:docMk/>
+            <pc:sldMk cId="0" sldId="257"/>
+            <ac:spMk id="18" creationId="{00000000-0000-0000-0000-000000000000}"/>
+          </ac:spMkLst>
+        </pc:spChg>
+      </pc:sldChg>
+      <pc:sldChg chg="modSp">
+        <pc:chgData name="FABRIZIO APUZZO" userId="S::fab.apuzzo@studenti.unina.it::d2e4b4f4-4f4c-4d22-be90-e12d8f7aad87" providerId="AD" clId="Web-{45BAA69B-9353-1306-EC09-7B692948B43F}" dt="2026-10-05T13:38:06.201" v="8" actId="20577"/>
+        <pc:sldMkLst>
+          <pc:docMk/>
+          <pc:sldMk cId="0" sldId="258"/>
+        </pc:sldMkLst>
+        <pc:spChg chg="mod">
+          <ac:chgData name="FABRIZIO APUZZO" userId="S::fab.apuzzo@studenti.unina.it::d2e4b4f4-4f4c-4d22-be90-e12d8f7aad87" providerId="AD" clId="Web-{45BAA69B-9353-1306-EC09-7B692948B43F}" dt="2026-10-05T13:38:06.201" v="8" actId="20577"/>
+          <ac:spMkLst>
+            <pc:docMk/>
+            <pc:sldMk cId="0" sldId="258"/>
+            <ac:spMk id="42" creationId="{00000000-0000-0000-0000-000000000000}"/>
+          </ac:spMkLst>
+        </pc:spChg>
+      </pc:sldChg>
+      <pc:sldChg chg="modSp">
+        <pc:chgData name="FABRIZIO APUZZO" userId="S::fab.apuzzo@studenti.unina.it::d2e4b4f4-4f4c-4d22-be90-e12d8f7aad87" providerId="AD" clId="Web-{45BAA69B-9353-1306-EC09-7B692948B43F}" dt="2026-10-05T13:59:01.343" v="47" actId="20577"/>
+        <pc:sldMkLst>
+          <pc:docMk/>
+          <pc:sldMk cId="0" sldId="261"/>
+        </pc:sldMkLst>
+        <pc:spChg chg="mod">
+          <ac:chgData name="FABRIZIO APUZZO" userId="S::fab.apuzzo@studenti.unina.it::d2e4b4f4-4f4c-4d22-be90-e12d8f7aad87" providerId="AD" clId="Web-{45BAA69B-9353-1306-EC09-7B692948B43F}" dt="2026-10-05T13:57:16.663" v="28" actId="20577"/>
+          <ac:spMkLst>
+            <pc:docMk/>
+            <pc:sldMk cId="0" sldId="261"/>
+            <ac:spMk id="7" creationId="{00000000-0000-0000-0000-000000000000}"/>
+          </ac:spMkLst>
+        </pc:spChg>
+        <pc:spChg chg="mod">
+          <ac:chgData name="FABRIZIO APUZZO" userId="S::fab.apuzzo@studenti.unina.it::d2e4b4f4-4f4c-4d22-be90-e12d8f7aad87" providerId="AD" clId="Web-{45BAA69B-9353-1306-EC09-7B692948B43F}" dt="2026-10-05T13:58:17.746" v="45" actId="20577"/>
+          <ac:spMkLst>
+            <pc:docMk/>
+            <pc:sldMk cId="0" sldId="261"/>
+            <ac:spMk id="11" creationId="{00000000-0000-0000-0000-000000000000}"/>
+          </ac:spMkLst>
+        </pc:spChg>
+        <pc:spChg chg="mod">
+          <ac:chgData name="FABRIZIO APUZZO" userId="S::fab.apuzzo@studenti.unina.it::d2e4b4f4-4f4c-4d22-be90-e12d8f7aad87" providerId="AD" clId="Web-{45BAA69B-9353-1306-EC09-7B692948B43F}" dt="2026-10-05T13:59:01.343" v="47" actId="20577"/>
+          <ac:spMkLst>
+            <pc:docMk/>
+            <pc:sldMk cId="0" sldId="261"/>
+            <ac:spMk id="13" creationId="{00000000-0000-0000-0000-000000000000}"/>
+          </ac:spMkLst>
+        </pc:spChg>
+      </pc:sldChg>
+      <pc:sldChg chg="modSp">
+        <pc:chgData name="FABRIZIO APUZZO" userId="S::fab.apuzzo@studenti.unina.it::d2e4b4f4-4f4c-4d22-be90-e12d8f7aad87" providerId="AD" clId="Web-{45BAA69B-9353-1306-EC09-7B692948B43F}" dt="2026-10-05T14:00:54.586" v="64" actId="20577"/>
+        <pc:sldMkLst>
+          <pc:docMk/>
+          <pc:sldMk cId="0" sldId="262"/>
+        </pc:sldMkLst>
+        <pc:spChg chg="mod">
+          <ac:chgData name="FABRIZIO APUZZO" userId="S::fab.apuzzo@studenti.unina.it::d2e4b4f4-4f4c-4d22-be90-e12d8f7aad87" providerId="AD" clId="Web-{45BAA69B-9353-1306-EC09-7B692948B43F}" dt="2026-10-05T14:00:22.177" v="60" actId="20577"/>
+          <ac:spMkLst>
+            <pc:docMk/>
+            <pc:sldMk cId="0" sldId="262"/>
+            <ac:spMk id="2" creationId="{00000000-0000-0000-0000-000000000000}"/>
+          </ac:spMkLst>
+        </pc:spChg>
+        <pc:spChg chg="mod">
+          <ac:chgData name="FABRIZIO APUZZO" userId="S::fab.apuzzo@studenti.unina.it::d2e4b4f4-4f4c-4d22-be90-e12d8f7aad87" providerId="AD" clId="Web-{45BAA69B-9353-1306-EC09-7B692948B43F}" dt="2026-10-05T14:00:54.586" v="64" actId="20577"/>
+          <ac:spMkLst>
+            <pc:docMk/>
+            <pc:sldMk cId="0" sldId="262"/>
+            <ac:spMk id="3" creationId="{00000000-0000-0000-0000-000000000000}"/>
+          </ac:spMkLst>
+        </pc:spChg>
+        <pc:spChg chg="mod">
+          <ac:chgData name="FABRIZIO APUZZO" userId="S::fab.apuzzo@studenti.unina.it::d2e4b4f4-4f4c-4d22-be90-e12d8f7aad87" providerId="AD" clId="Web-{45BAA69B-9353-1306-EC09-7B692948B43F}" dt="2026-10-05T13:59:35.502" v="50" actId="20577"/>
+          <ac:spMkLst>
+            <pc:docMk/>
+            <pc:sldMk cId="0" sldId="262"/>
+            <ac:spMk id="21" creationId="{00000000-0000-0000-0000-000000000000}"/>
+          </ac:spMkLst>
+        </pc:spChg>
+        <pc:spChg chg="mod">
+          <ac:chgData name="FABRIZIO APUZZO" userId="S::fab.apuzzo@studenti.unina.it::d2e4b4f4-4f4c-4d22-be90-e12d8f7aad87" providerId="AD" clId="Web-{45BAA69B-9353-1306-EC09-7B692948B43F}" dt="2026-10-05T13:59:57.957" v="52" actId="20577"/>
+          <ac:spMkLst>
+            <pc:docMk/>
+            <pc:sldMk cId="0" sldId="262"/>
+            <ac:spMk id="29" creationId="{00000000-0000-0000-0000-000000000000}"/>
+          </ac:spMkLst>
+        </pc:spChg>
+      </pc:sldChg>
+      <pc:sldChg chg="modSp">
+        <pc:chgData name="FABRIZIO APUZZO" userId="S::fab.apuzzo@studenti.unina.it::d2e4b4f4-4f4c-4d22-be90-e12d8f7aad87" providerId="AD" clId="Web-{45BAA69B-9353-1306-EC09-7B692948B43F}" dt="2026-10-05T14:52:59.092" v="527" actId="1076"/>
+        <pc:sldMkLst>
+          <pc:docMk/>
+          <pc:sldMk cId="0" sldId="263"/>
+        </pc:sldMkLst>
+        <pc:spChg chg="mod">
+          <ac:chgData name="FABRIZIO APUZZO" userId="S::fab.apuzzo@studenti.unina.it::d2e4b4f4-4f4c-4d22-be90-e12d8f7aad87" providerId="AD" clId="Web-{45BAA69B-9353-1306-EC09-7B692948B43F}" dt="2026-10-05T14:52:59.092" v="527" actId="1076"/>
+          <ac:spMkLst>
+            <pc:docMk/>
+            <pc:sldMk cId="0" sldId="263"/>
+            <ac:spMk id="2" creationId="{00000000-0000-0000-0000-000000000000}"/>
+          </ac:spMkLst>
+        </pc:spChg>
+        <pc:spChg chg="mod">
+          <ac:chgData name="FABRIZIO APUZZO" userId="S::fab.apuzzo@studenti.unina.it::d2e4b4f4-4f4c-4d22-be90-e12d8f7aad87" providerId="AD" clId="Web-{45BAA69B-9353-1306-EC09-7B692948B43F}" dt="2026-10-05T14:06:08.657" v="89" actId="20577"/>
+          <ac:spMkLst>
+            <pc:docMk/>
+            <pc:sldMk cId="0" sldId="263"/>
+            <ac:spMk id="3" creationId="{00000000-0000-0000-0000-000000000000}"/>
+          </ac:spMkLst>
+        </pc:spChg>
+        <pc:spChg chg="mod">
+          <ac:chgData name="FABRIZIO APUZZO" userId="S::fab.apuzzo@studenti.unina.it::d2e4b4f4-4f4c-4d22-be90-e12d8f7aad87" providerId="AD" clId="Web-{45BAA69B-9353-1306-EC09-7B692948B43F}" dt="2026-10-05T14:16:07.734" v="504" actId="20577"/>
+          <ac:spMkLst>
+            <pc:docMk/>
+            <pc:sldMk cId="0" sldId="263"/>
+            <ac:spMk id="10" creationId="{00000000-0000-0000-0000-000000000000}"/>
+          </ac:spMkLst>
+        </pc:spChg>
+        <pc:spChg chg="mod">
+          <ac:chgData name="FABRIZIO APUZZO" userId="S::fab.apuzzo@studenti.unina.it::d2e4b4f4-4f4c-4d22-be90-e12d8f7aad87" providerId="AD" clId="Web-{45BAA69B-9353-1306-EC09-7B692948B43F}" dt="2026-10-05T14:52:58.201" v="526" actId="20577"/>
+          <ac:spMkLst>
+            <pc:docMk/>
+            <pc:sldMk cId="0" sldId="263"/>
+            <ac:spMk id="14" creationId="{00000000-0000-0000-0000-000000000000}"/>
+          </ac:spMkLst>
+        </pc:spChg>
+        <pc:spChg chg="mod">
+          <ac:chgData name="FABRIZIO APUZZO" userId="S::fab.apuzzo@studenti.unina.it::d2e4b4f4-4f4c-4d22-be90-e12d8f7aad87" providerId="AD" clId="Web-{45BAA69B-9353-1306-EC09-7B692948B43F}" dt="2026-10-05T14:21:24.087" v="507" actId="20577"/>
+          <ac:spMkLst>
+            <pc:docMk/>
+            <pc:sldMk cId="0" sldId="263"/>
+            <ac:spMk id="22" creationId="{00000000-0000-0000-0000-000000000000}"/>
+          </ac:spMkLst>
+        </pc:spChg>
+      </pc:sldChg>
+      <pc:sldChg chg="modSp">
+        <pc:chgData name="FABRIZIO APUZZO" userId="S::fab.apuzzo@studenti.unina.it::d2e4b4f4-4f4c-4d22-be90-e12d8f7aad87" providerId="AD" clId="Web-{45BAA69B-9353-1306-EC09-7B692948B43F}" dt="2026-10-05T14:46:22.249" v="509" actId="20577"/>
+        <pc:sldMkLst>
+          <pc:docMk/>
+          <pc:sldMk cId="0" sldId="265"/>
+        </pc:sldMkLst>
+        <pc:spChg chg="mod">
+          <ac:chgData name="FABRIZIO APUZZO" userId="S::fab.apuzzo@studenti.unina.it::d2e4b4f4-4f4c-4d22-be90-e12d8f7aad87" providerId="AD" clId="Web-{45BAA69B-9353-1306-EC09-7B692948B43F}" dt="2026-10-05T14:46:22.249" v="509" actId="20577"/>
+          <ac:spMkLst>
+            <pc:docMk/>
+            <pc:sldMk cId="0" sldId="265"/>
+            <ac:spMk id="10" creationId="{00000000-0000-0000-0000-000000000000}"/>
+          </ac:spMkLst>
+        </pc:spChg>
+      </pc:sldChg>
+    </pc:docChg>
+  </pc:docChgLst>
 </pc:chgInfo>
 </file>
 
@@ -2910,8 +2910,272 @@
           <a:lstStyle/>
           <a:p>
             <a:r>
-              <a:rPr lang="en-US"/>
-              <a:t>Prima di scrivere qualsiasi riga di codice abbiamo studiato la teoria del corso. Barry Boehm ci insegna che nelle fasi iniziali di fattibilità l'incertezza spazia da un quarto a quattro volte la realtà. Ma il manager deve formulare un budget proprio in quel momento. Perché non usare le righe di codice? Perché all'inizio le righe sono zero, e comunque dipendono fortemente dal linguaggio usato.</a:t>
+              <a:rPr lang="en-US" dirty="0"/>
+              <a:t>Prima di </a:t>
+            </a:r>
+            <a:r>
+              <a:rPr lang="en-US" dirty="0" err="1"/>
+              <a:t>scrivere</a:t>
+            </a:r>
+            <a:r>
+              <a:rPr lang="en-US" dirty="0"/>
+              <a:t> </a:t>
+            </a:r>
+            <a:r>
+              <a:rPr lang="en-US" dirty="0" err="1"/>
+              <a:t>qualsiasi</a:t>
+            </a:r>
+            <a:r>
+              <a:rPr lang="en-US" dirty="0"/>
+              <a:t> </a:t>
+            </a:r>
+            <a:r>
+              <a:rPr lang="en-US" dirty="0" err="1"/>
+              <a:t>riga</a:t>
+            </a:r>
+            <a:r>
+              <a:rPr lang="en-US" dirty="0"/>
+              <a:t> di </a:t>
+            </a:r>
+            <a:r>
+              <a:rPr lang="en-US" dirty="0" err="1"/>
+              <a:t>codice</a:t>
+            </a:r>
+            <a:r>
+              <a:rPr lang="en-US" dirty="0"/>
+              <a:t> </a:t>
+            </a:r>
+            <a:r>
+              <a:rPr lang="en-US" dirty="0" err="1"/>
+              <a:t>abbiamo</a:t>
+            </a:r>
+            <a:r>
+              <a:rPr lang="en-US" dirty="0"/>
+              <a:t> </a:t>
+            </a:r>
+            <a:r>
+              <a:rPr lang="en-US" dirty="0" err="1"/>
+              <a:t>studiato</a:t>
+            </a:r>
+            <a:r>
+              <a:rPr lang="en-US" dirty="0"/>
+              <a:t> la </a:t>
+            </a:r>
+            <a:r>
+              <a:rPr lang="en-US" dirty="0" err="1"/>
+              <a:t>teoria</a:t>
+            </a:r>
+            <a:r>
+              <a:rPr lang="en-US" dirty="0"/>
+              <a:t> del </a:t>
+            </a:r>
+            <a:r>
+              <a:rPr lang="en-US" dirty="0" err="1"/>
+              <a:t>corso</a:t>
+            </a:r>
+            <a:r>
+              <a:rPr lang="en-US" dirty="0"/>
+              <a:t>. Barry Boehm ci </a:t>
+            </a:r>
+            <a:r>
+              <a:rPr lang="en-US" dirty="0" err="1"/>
+              <a:t>insegna</a:t>
+            </a:r>
+            <a:r>
+              <a:rPr lang="en-US" dirty="0"/>
+              <a:t> </a:t>
+            </a:r>
+            <a:r>
+              <a:rPr lang="en-US" dirty="0" err="1"/>
+              <a:t>che</a:t>
+            </a:r>
+            <a:r>
+              <a:rPr lang="en-US" dirty="0"/>
+              <a:t> </a:t>
+            </a:r>
+            <a:r>
+              <a:rPr lang="en-US" dirty="0" err="1"/>
+              <a:t>nelle</a:t>
+            </a:r>
+            <a:r>
+              <a:rPr lang="en-US" dirty="0"/>
+              <a:t> </a:t>
+            </a:r>
+            <a:r>
+              <a:rPr lang="en-US" dirty="0" err="1"/>
+              <a:t>fasi</a:t>
+            </a:r>
+            <a:r>
+              <a:rPr lang="en-US" dirty="0"/>
+              <a:t> </a:t>
+            </a:r>
+            <a:r>
+              <a:rPr lang="en-US" dirty="0" err="1"/>
+              <a:t>iniziali</a:t>
+            </a:r>
+            <a:r>
+              <a:rPr lang="en-US" dirty="0"/>
+              <a:t> di </a:t>
+            </a:r>
+            <a:r>
+              <a:rPr lang="en-US" dirty="0" err="1"/>
+              <a:t>fattibilità</a:t>
+            </a:r>
+            <a:r>
+              <a:rPr lang="en-US" dirty="0"/>
+              <a:t> </a:t>
+            </a:r>
+            <a:r>
+              <a:rPr lang="en-US" dirty="0" err="1"/>
+              <a:t>l'incertezza</a:t>
+            </a:r>
+            <a:r>
+              <a:rPr lang="en-US" dirty="0"/>
+              <a:t> </a:t>
+            </a:r>
+            <a:r>
+              <a:rPr lang="en-US" dirty="0" err="1"/>
+              <a:t>spazia</a:t>
+            </a:r>
+            <a:r>
+              <a:rPr lang="en-US" dirty="0"/>
+              <a:t> da un quarto a quattro volte la </a:t>
+            </a:r>
+            <a:r>
+              <a:rPr lang="en-US" dirty="0" err="1"/>
+              <a:t>realtà</a:t>
+            </a:r>
+            <a:r>
+              <a:rPr lang="en-US" dirty="0"/>
+              <a:t>. Ma il manager </a:t>
+            </a:r>
+            <a:r>
+              <a:rPr lang="en-US" dirty="0" err="1"/>
+              <a:t>deve</a:t>
+            </a:r>
+            <a:r>
+              <a:rPr lang="en-US" dirty="0"/>
+              <a:t> </a:t>
+            </a:r>
+            <a:r>
+              <a:rPr lang="en-US" dirty="0" err="1"/>
+              <a:t>formulare</a:t>
+            </a:r>
+            <a:r>
+              <a:rPr lang="en-US" dirty="0"/>
+              <a:t> un budget proprio in </a:t>
+            </a:r>
+            <a:r>
+              <a:rPr lang="en-US" dirty="0" err="1"/>
+              <a:t>quel</a:t>
+            </a:r>
+            <a:r>
+              <a:rPr lang="en-US" dirty="0"/>
+              <a:t> </a:t>
+            </a:r>
+            <a:r>
+              <a:rPr lang="en-US" dirty="0" err="1"/>
+              <a:t>momento</a:t>
+            </a:r>
+            <a:r>
+              <a:rPr lang="en-US" dirty="0"/>
+              <a:t>. </a:t>
+            </a:r>
+            <a:r>
+              <a:rPr lang="en-US" dirty="0" err="1"/>
+              <a:t>Perché</a:t>
+            </a:r>
+            <a:r>
+              <a:rPr lang="en-US" dirty="0"/>
+              <a:t> non </a:t>
+            </a:r>
+            <a:r>
+              <a:rPr lang="en-US" dirty="0" err="1"/>
+              <a:t>usare</a:t>
+            </a:r>
+            <a:r>
+              <a:rPr lang="en-US" dirty="0"/>
+              <a:t> le </a:t>
+            </a:r>
+            <a:r>
+              <a:rPr lang="en-US" dirty="0" err="1"/>
+              <a:t>righe</a:t>
+            </a:r>
+            <a:r>
+              <a:rPr lang="en-US" dirty="0"/>
+              <a:t> di </a:t>
+            </a:r>
+            <a:r>
+              <a:rPr lang="en-US" dirty="0" err="1"/>
+              <a:t>codice</a:t>
+            </a:r>
+            <a:r>
+              <a:rPr lang="en-US" dirty="0"/>
+              <a:t>? </a:t>
+            </a:r>
+            <a:r>
+              <a:rPr lang="en-US" dirty="0" err="1"/>
+              <a:t>Perché</a:t>
+            </a:r>
+            <a:r>
+              <a:rPr lang="en-US" dirty="0"/>
+              <a:t> </a:t>
+            </a:r>
+            <a:r>
+              <a:rPr lang="en-US" dirty="0" err="1"/>
+              <a:t>all'inizio</a:t>
+            </a:r>
+            <a:r>
+              <a:rPr lang="en-US" dirty="0"/>
+              <a:t> le </a:t>
+            </a:r>
+            <a:r>
+              <a:rPr lang="en-US" dirty="0" err="1"/>
+              <a:t>righe</a:t>
+            </a:r>
+            <a:r>
+              <a:rPr lang="en-US" dirty="0"/>
+              <a:t> </a:t>
+            </a:r>
+            <a:r>
+              <a:rPr lang="en-US" dirty="0" err="1"/>
+              <a:t>sono</a:t>
+            </a:r>
+            <a:r>
+              <a:rPr lang="en-US" dirty="0"/>
+              <a:t> zero, e </a:t>
+            </a:r>
+            <a:r>
+              <a:rPr lang="en-US" dirty="0" err="1"/>
+              <a:t>comunque</a:t>
+            </a:r>
+            <a:r>
+              <a:rPr lang="en-US" dirty="0"/>
+              <a:t> </a:t>
+            </a:r>
+            <a:r>
+              <a:rPr lang="en-US" dirty="0" err="1"/>
+              <a:t>dipendono</a:t>
+            </a:r>
+            <a:r>
+              <a:rPr lang="en-US" dirty="0"/>
+              <a:t> fortemente dal </a:t>
+            </a:r>
+            <a:r>
+              <a:rPr lang="en-US" dirty="0" err="1"/>
+              <a:t>linguaggio</a:t>
+            </a:r>
+            <a:r>
+              <a:rPr lang="en-US" dirty="0"/>
+              <a:t> </a:t>
+            </a:r>
+            <a:r>
+              <a:rPr lang="en-US" dirty="0" err="1"/>
+              <a:t>usato</a:t>
+            </a:r>
+            <a:r>
+              <a:rPr lang="en-US" dirty="0"/>
+              <a:t>.</a:t>
             </a:r>
           </a:p>
         </p:txBody>
@@ -16551,7 +16815,7 @@
               </a:lnSpc>
             </a:pPr>
             <a:r>
-              <a:rPr lang="en-US" sz="900" err="1">
+              <a:rPr lang="en-US" sz="900" dirty="0" err="1">
                 <a:solidFill>
                   <a:srgbClr val="334155"/>
                 </a:solidFill>
@@ -16562,7 +16826,7 @@
               <a:t>Invece</a:t>
             </a:r>
             <a:r>
-              <a:rPr lang="en-US" sz="900">
+              <a:rPr lang="en-US" sz="900" dirty="0">
                 <a:solidFill>
                   <a:srgbClr val="334155"/>
                 </a:solidFill>
@@ -16573,7 +16837,7 @@
               <a:t> di </a:t>
             </a:r>
             <a:r>
-              <a:rPr lang="en-US" sz="900" err="1">
+              <a:rPr lang="en-US" sz="900" dirty="0" err="1">
                 <a:solidFill>
                   <a:srgbClr val="334155"/>
                 </a:solidFill>
@@ -16584,7 +16848,7 @@
               <a:t>affidarsi</a:t>
             </a:r>
             <a:r>
-              <a:rPr lang="en-US" sz="900">
+              <a:rPr lang="en-US" sz="900" dirty="0">
                 <a:solidFill>
                   <a:srgbClr val="334155"/>
                 </a:solidFill>
@@ -16595,7 +16859,7 @@
               <a:t> </a:t>
             </a:r>
             <a:r>
-              <a:rPr lang="en-US" sz="900" err="1">
+              <a:rPr lang="en-US" sz="900" dirty="0" err="1">
                 <a:solidFill>
                   <a:srgbClr val="334155"/>
                 </a:solidFill>
@@ -16606,7 +16870,7 @@
               <a:t>unicamente</a:t>
             </a:r>
             <a:r>
-              <a:rPr lang="en-US" sz="900">
+              <a:rPr lang="en-US" sz="900" dirty="0">
                 <a:solidFill>
                   <a:srgbClr val="334155"/>
                 </a:solidFill>
@@ -16617,7 +16881,7 @@
               <a:t> a </a:t>
             </a:r>
             <a:r>
-              <a:rPr lang="en-US" sz="900" err="1">
+              <a:rPr lang="en-US" sz="900" dirty="0" err="1">
                 <a:solidFill>
                   <a:srgbClr val="334155"/>
                 </a:solidFill>
@@ -16628,7 +16892,7 @@
               <a:t>formule</a:t>
             </a:r>
             <a:r>
-              <a:rPr lang="en-US" sz="900">
+              <a:rPr lang="en-US" sz="900" dirty="0">
                 <a:solidFill>
                   <a:srgbClr val="334155"/>
                 </a:solidFill>
@@ -16639,7 +16903,7 @@
               <a:t> </a:t>
             </a:r>
             <a:r>
-              <a:rPr lang="en-US" sz="900" err="1">
+              <a:rPr lang="en-US" sz="900" dirty="0" err="1">
                 <a:solidFill>
                   <a:srgbClr val="334155"/>
                 </a:solidFill>
@@ -16650,7 +16914,7 @@
               <a:t>precalcolate</a:t>
             </a:r>
             <a:r>
-              <a:rPr lang="en-US" sz="900">
+              <a:rPr lang="en-US" sz="900" dirty="0">
                 <a:solidFill>
                   <a:srgbClr val="334155"/>
                 </a:solidFill>
@@ -16661,7 +16925,7 @@
               <a:t> </a:t>
             </a:r>
             <a:r>
-              <a:rPr lang="en-US" sz="900" err="1">
+              <a:rPr lang="en-US" sz="900" dirty="0" err="1">
                 <a:solidFill>
                   <a:srgbClr val="334155"/>
                 </a:solidFill>
@@ -16672,7 +16936,7 @@
               <a:t>che</a:t>
             </a:r>
             <a:r>
-              <a:rPr lang="en-US" sz="900">
+              <a:rPr lang="en-US" sz="900" dirty="0">
                 <a:solidFill>
                   <a:srgbClr val="334155"/>
                 </a:solidFill>
@@ -16683,18 +16947,18 @@
               <a:t> </a:t>
             </a:r>
             <a:r>
-              <a:rPr lang="en-US" sz="900" err="1">
-                <a:solidFill>
-                  <a:srgbClr val="334155"/>
-                </a:solidFill>
-                <a:latin typeface="Arial"/>
-                <a:ea typeface="Arial" pitchFamily="34" charset="-122"/>
-                <a:cs typeface="Arial"/>
-              </a:rPr>
-              <a:t>diventano</a:t>
-            </a:r>
-            <a:r>
-              <a:rPr lang="en-US" sz="900">
+              <a:rPr lang="en-US" sz="900" dirty="0" err="1">
+                <a:solidFill>
+                  <a:srgbClr val="334155"/>
+                </a:solidFill>
+                <a:latin typeface="Arial"/>
+                <a:ea typeface="Arial" pitchFamily="34" charset="-122"/>
+                <a:cs typeface="Arial"/>
+              </a:rPr>
+              <a:t>possono</a:t>
+            </a:r>
+            <a:r>
+              <a:rPr lang="en-US" sz="900" dirty="0">
                 <a:solidFill>
                   <a:srgbClr val="334155"/>
                 </a:solidFill>
@@ -16705,29 +16969,51 @@
               <a:t> </a:t>
             </a:r>
             <a:r>
-              <a:rPr lang="en-US" sz="900" err="1">
-                <a:solidFill>
-                  <a:srgbClr val="334155"/>
-                </a:solidFill>
-                <a:latin typeface="Arial"/>
-                <a:ea typeface="Arial" pitchFamily="34" charset="-122"/>
-                <a:cs typeface="Arial"/>
-              </a:rPr>
-              <a:t>facilmente</a:t>
-            </a:r>
-            <a:r>
-              <a:rPr lang="en-US" sz="900">
-                <a:solidFill>
-                  <a:srgbClr val="334155"/>
-                </a:solidFill>
-                <a:latin typeface="Arial"/>
-                <a:ea typeface="Arial" pitchFamily="34" charset="-122"/>
-                <a:cs typeface="Arial"/>
-              </a:rPr>
-              <a:t> obsolete, </a:t>
-            </a:r>
-            <a:r>
-              <a:rPr lang="en-US" sz="900" err="1">
+              <a:rPr lang="en-US" sz="900" dirty="0" err="1">
+                <a:solidFill>
+                  <a:srgbClr val="334155"/>
+                </a:solidFill>
+                <a:latin typeface="Arial"/>
+                <a:ea typeface="Arial" pitchFamily="34" charset="-122"/>
+                <a:cs typeface="Arial"/>
+              </a:rPr>
+              <a:t>essere</a:t>
+            </a:r>
+            <a:r>
+              <a:rPr lang="en-US" sz="900" dirty="0">
+                <a:solidFill>
+                  <a:srgbClr val="334155"/>
+                </a:solidFill>
+                <a:latin typeface="Arial"/>
+                <a:ea typeface="Arial" pitchFamily="34" charset="-122"/>
+                <a:cs typeface="Arial"/>
+              </a:rPr>
+              <a:t> </a:t>
+            </a:r>
+            <a:r>
+              <a:rPr lang="en-US" sz="900" dirty="0" err="1">
+                <a:solidFill>
+                  <a:srgbClr val="334155"/>
+                </a:solidFill>
+                <a:latin typeface="Arial"/>
+                <a:ea typeface="Arial" pitchFamily="34" charset="-122"/>
+                <a:cs typeface="Arial"/>
+              </a:rPr>
+              <a:t>limitate</a:t>
+            </a:r>
+            <a:r>
+              <a:rPr lang="en-US" sz="900" dirty="0">
+                <a:solidFill>
+                  <a:srgbClr val="334155"/>
+                </a:solidFill>
+                <a:latin typeface="Arial"/>
+                <a:ea typeface="Arial" pitchFamily="34" charset="-122"/>
+                <a:cs typeface="Arial"/>
+              </a:rPr>
+              <a:t>, </a:t>
+            </a:r>
+            <a:r>
+              <a:rPr lang="en-US" sz="900" dirty="0" err="1">
                 <a:solidFill>
                   <a:srgbClr val="334155"/>
                 </a:solidFill>
@@ -16738,7 +17024,7 @@
               <a:t>si</a:t>
             </a:r>
             <a:r>
-              <a:rPr lang="en-US" sz="900">
+              <a:rPr lang="en-US" sz="900" dirty="0">
                 <a:solidFill>
                   <a:srgbClr val="334155"/>
                 </a:solidFill>
@@ -16749,7 +17035,7 @@
               <a:t> </a:t>
             </a:r>
             <a:r>
-              <a:rPr lang="en-US" sz="900" err="1">
+              <a:rPr lang="en-US" sz="900" dirty="0" err="1">
                 <a:solidFill>
                   <a:srgbClr val="334155"/>
                 </a:solidFill>
@@ -16760,7 +17046,7 @@
               <a:t>può</a:t>
             </a:r>
             <a:r>
-              <a:rPr lang="en-US" sz="900">
+              <a:rPr lang="en-US" sz="900" dirty="0">
                 <a:solidFill>
                   <a:srgbClr val="334155"/>
                 </a:solidFill>
@@ -16771,7 +17057,7 @@
               <a:t> fare </a:t>
             </a:r>
             <a:r>
-              <a:rPr lang="en-US" sz="900" err="1">
+              <a:rPr lang="en-US" sz="900" dirty="0" err="1">
                 <a:solidFill>
                   <a:srgbClr val="334155"/>
                 </a:solidFill>
@@ -16782,7 +17068,7 @@
               <a:t>riferimento</a:t>
             </a:r>
             <a:r>
-              <a:rPr lang="en-US" sz="900">
+              <a:rPr lang="en-US" sz="900" dirty="0">
                 <a:solidFill>
                   <a:srgbClr val="334155"/>
                 </a:solidFill>
@@ -16793,7 +17079,7 @@
               <a:t> ai </a:t>
             </a:r>
             <a:r>
-              <a:rPr lang="en-US" sz="900" err="1">
+              <a:rPr lang="en-US" sz="900" dirty="0" err="1">
                 <a:solidFill>
                   <a:srgbClr val="334155"/>
                 </a:solidFill>
@@ -16804,7 +17090,7 @@
               <a:t>modelli</a:t>
             </a:r>
             <a:r>
-              <a:rPr lang="en-US" sz="900">
+              <a:rPr lang="en-US" sz="900" dirty="0">
                 <a:solidFill>
                   <a:srgbClr val="334155"/>
                 </a:solidFill>
@@ -16815,7 +17101,7 @@
               <a:t> di Machine Learning, </a:t>
             </a:r>
             <a:r>
-              <a:rPr lang="en-US" sz="900" err="1">
+              <a:rPr lang="en-US" sz="900" dirty="0" err="1">
                 <a:solidFill>
                   <a:srgbClr val="334155"/>
                 </a:solidFill>
@@ -16826,7 +17112,7 @@
               <a:t>che</a:t>
             </a:r>
             <a:r>
-              <a:rPr lang="en-US" sz="900">
+              <a:rPr lang="en-US" sz="900" dirty="0">
                 <a:solidFill>
                   <a:srgbClr val="334155"/>
                 </a:solidFill>
@@ -16837,7 +17123,7 @@
               <a:t> </a:t>
             </a:r>
             <a:r>
-              <a:rPr lang="en-US" sz="900" err="1">
+              <a:rPr lang="en-US" sz="900" dirty="0" err="1">
                 <a:solidFill>
                   <a:srgbClr val="334155"/>
                 </a:solidFill>
@@ -16848,7 +17134,7 @@
               <a:t>sono</a:t>
             </a:r>
             <a:r>
-              <a:rPr lang="en-US" sz="900">
+              <a:rPr lang="en-US" sz="900" dirty="0">
                 <a:solidFill>
                   <a:srgbClr val="334155"/>
                 </a:solidFill>
@@ -16859,7 +17145,7 @@
               <a:t> </a:t>
             </a:r>
             <a:r>
-              <a:rPr lang="en-US" sz="900" err="1">
+              <a:rPr lang="en-US" sz="900" dirty="0" err="1">
                 <a:solidFill>
                   <a:srgbClr val="334155"/>
                 </a:solidFill>
@@ -16870,7 +17156,7 @@
               <a:t>capaci</a:t>
             </a:r>
             <a:r>
-              <a:rPr lang="en-US" sz="900">
+              <a:rPr lang="en-US" sz="900" dirty="0">
                 <a:solidFill>
                   <a:srgbClr val="334155"/>
                 </a:solidFill>
@@ -16881,7 +17167,7 @@
               <a:t> di "</a:t>
             </a:r>
             <a:r>
-              <a:rPr lang="en-US" sz="900" err="1">
+              <a:rPr lang="en-US" sz="900" dirty="0" err="1">
                 <a:solidFill>
                   <a:srgbClr val="334155"/>
                 </a:solidFill>
@@ -16892,7 +17178,7 @@
               <a:t>apprendere</a:t>
             </a:r>
             <a:r>
-              <a:rPr lang="en-US" sz="900">
+              <a:rPr lang="en-US" sz="900" dirty="0">
                 <a:solidFill>
                   <a:srgbClr val="334155"/>
                 </a:solidFill>
@@ -16903,7 +17189,7 @@
               <a:t>" le </a:t>
             </a:r>
             <a:r>
-              <a:rPr lang="en-US" sz="900" err="1">
+              <a:rPr lang="en-US" sz="900" dirty="0" err="1">
                 <a:solidFill>
                   <a:srgbClr val="334155"/>
                 </a:solidFill>
@@ -16914,7 +17200,7 @@
               <a:t>correlazioni</a:t>
             </a:r>
             <a:r>
-              <a:rPr lang="en-US" sz="900">
+              <a:rPr lang="en-US" sz="900" dirty="0">
                 <a:solidFill>
                   <a:srgbClr val="334155"/>
                 </a:solidFill>
@@ -16925,7 +17211,7 @@
               <a:t> </a:t>
             </a:r>
             <a:r>
-              <a:rPr lang="en-US" sz="900" err="1">
+              <a:rPr lang="en-US" sz="900" dirty="0" err="1">
                 <a:solidFill>
                   <a:srgbClr val="334155"/>
                 </a:solidFill>
@@ -16936,7 +17222,7 @@
               <a:t>nascoste</a:t>
             </a:r>
             <a:r>
-              <a:rPr lang="en-US" sz="900">
+              <a:rPr lang="en-US" sz="900" dirty="0">
                 <a:solidFill>
                   <a:srgbClr val="334155"/>
                 </a:solidFill>
@@ -16947,7 +17233,7 @@
               <a:t> </a:t>
             </a:r>
             <a:r>
-              <a:rPr lang="en-US" sz="900" err="1">
+              <a:rPr lang="en-US" sz="900" dirty="0" err="1">
                 <a:solidFill>
                   <a:srgbClr val="334155"/>
                 </a:solidFill>
@@ -16958,7 +17244,7 @@
               <a:t>dai</a:t>
             </a:r>
             <a:r>
-              <a:rPr lang="en-US" sz="900">
+              <a:rPr lang="en-US" sz="900" dirty="0">
                 <a:solidFill>
                   <a:srgbClr val="334155"/>
                 </a:solidFill>
@@ -16969,7 +17255,7 @@
               <a:t> </a:t>
             </a:r>
             <a:r>
-              <a:rPr lang="en-US" sz="900" err="1">
+              <a:rPr lang="en-US" sz="900" dirty="0" err="1">
                 <a:solidFill>
                   <a:srgbClr val="334155"/>
                 </a:solidFill>
@@ -16980,7 +17266,7 @@
               <a:t>dati</a:t>
             </a:r>
             <a:r>
-              <a:rPr lang="en-US" sz="900">
+              <a:rPr lang="en-US" sz="900" dirty="0">
                 <a:solidFill>
                   <a:srgbClr val="334155"/>
                 </a:solidFill>
@@ -16991,7 +17277,7 @@
               <a:t> </a:t>
             </a:r>
             <a:r>
-              <a:rPr lang="en-US" sz="900" err="1">
+              <a:rPr lang="en-US" sz="900" dirty="0" err="1">
                 <a:solidFill>
                   <a:srgbClr val="334155"/>
                 </a:solidFill>
@@ -17002,7 +17288,7 @@
               <a:t>storici</a:t>
             </a:r>
             <a:r>
-              <a:rPr lang="en-US" sz="900">
+              <a:rPr lang="en-US" sz="900" dirty="0">
                 <a:solidFill>
                   <a:srgbClr val="334155"/>
                 </a:solidFill>
@@ -17013,7 +17299,7 @@
               <a:t> </a:t>
             </a:r>
             <a:r>
-              <a:rPr lang="en-US" sz="900" err="1">
+              <a:rPr lang="en-US" sz="900" dirty="0" err="1">
                 <a:solidFill>
                   <a:srgbClr val="334155"/>
                 </a:solidFill>
@@ -17024,7 +17310,7 @@
               <a:t>dei</a:t>
             </a:r>
             <a:r>
-              <a:rPr lang="en-US" sz="900">
+              <a:rPr lang="en-US" sz="900" dirty="0">
                 <a:solidFill>
                   <a:srgbClr val="334155"/>
                 </a:solidFill>
@@ -17035,7 +17321,7 @@
               <a:t> </a:t>
             </a:r>
             <a:r>
-              <a:rPr lang="en-US" sz="900" err="1">
+              <a:rPr lang="en-US" sz="900" dirty="0" err="1">
                 <a:solidFill>
                   <a:srgbClr val="334155"/>
                 </a:solidFill>
@@ -17046,7 +17332,7 @@
               <a:t>progetti</a:t>
             </a:r>
             <a:r>
-              <a:rPr lang="en-US" sz="900">
+              <a:rPr lang="en-US" sz="900" dirty="0">
                 <a:solidFill>
                   <a:srgbClr val="334155"/>
                 </a:solidFill>
@@ -17057,7 +17343,7 @@
               <a:t> software </a:t>
             </a:r>
             <a:r>
-              <a:rPr lang="en-US" sz="900" err="1">
+              <a:rPr lang="en-US" sz="900" dirty="0" err="1">
                 <a:solidFill>
                   <a:srgbClr val="334155"/>
                 </a:solidFill>
@@ -17068,7 +17354,7 @@
               <a:t>reali</a:t>
             </a:r>
             <a:r>
-              <a:rPr lang="en-US" sz="900">
+              <a:rPr lang="en-US" sz="900" dirty="0">
                 <a:solidFill>
                   <a:srgbClr val="334155"/>
                 </a:solidFill>
@@ -17078,7 +17364,7 @@
               </a:rPr>
               <a:t>.</a:t>
             </a:r>
-            <a:endParaRPr lang="en-US" sz="900">
+            <a:endParaRPr lang="en-US" sz="900" dirty="0">
               <a:latin typeface="Arial"/>
               <a:cs typeface="Arial"/>
             </a:endParaRPr>
@@ -25364,18 +25650,62 @@
               </a:lnSpc>
             </a:pPr>
             <a:r>
-              <a:rPr lang="en-US" sz="850">
-                <a:solidFill>
-                  <a:srgbClr val="334155"/>
-                </a:solidFill>
-                <a:latin typeface="Arial"/>
-                <a:ea typeface="Arial" pitchFamily="34" charset="-122"/>
-                <a:cs typeface="Arial"/>
-              </a:rPr>
-              <a:t>Non assegna il progetto a un cluster </a:t>
-            </a:r>
-            <a:r>
-              <a:rPr lang="en-US" sz="850" err="1">
+              <a:rPr lang="en-US" sz="850" dirty="0">
+                <a:solidFill>
+                  <a:srgbClr val="334155"/>
+                </a:solidFill>
+                <a:latin typeface="Arial"/>
+                <a:ea typeface="Arial" pitchFamily="34" charset="-122"/>
+                <a:cs typeface="Arial"/>
+              </a:rPr>
+              <a:t>Non </a:t>
+            </a:r>
+            <a:r>
+              <a:rPr lang="en-US" sz="850" dirty="0" err="1">
+                <a:solidFill>
+                  <a:srgbClr val="334155"/>
+                </a:solidFill>
+                <a:latin typeface="Arial"/>
+                <a:ea typeface="Arial" pitchFamily="34" charset="-122"/>
+                <a:cs typeface="Arial"/>
+              </a:rPr>
+              <a:t>assegna</a:t>
+            </a:r>
+            <a:r>
+              <a:rPr lang="en-US" sz="850" dirty="0">
+                <a:solidFill>
+                  <a:srgbClr val="334155"/>
+                </a:solidFill>
+                <a:latin typeface="Arial"/>
+                <a:ea typeface="Arial" pitchFamily="34" charset="-122"/>
+                <a:cs typeface="Arial"/>
+              </a:rPr>
+              <a:t> il </a:t>
+            </a:r>
+            <a:r>
+              <a:rPr lang="en-US" sz="850" dirty="0" err="1">
+                <a:solidFill>
+                  <a:srgbClr val="334155"/>
+                </a:solidFill>
+                <a:latin typeface="Arial"/>
+                <a:ea typeface="Arial" pitchFamily="34" charset="-122"/>
+                <a:cs typeface="Arial"/>
+              </a:rPr>
+              <a:t>progetto</a:t>
+            </a:r>
+            <a:r>
+              <a:rPr lang="en-US" sz="850" dirty="0">
+                <a:solidFill>
+                  <a:srgbClr val="334155"/>
+                </a:solidFill>
+                <a:latin typeface="Arial"/>
+                <a:ea typeface="Arial" pitchFamily="34" charset="-122"/>
+                <a:cs typeface="Arial"/>
+              </a:rPr>
+              <a:t> a un cluster </a:t>
+            </a:r>
+            <a:r>
+              <a:rPr lang="en-US" sz="850" dirty="0" err="1">
                 <a:solidFill>
                   <a:srgbClr val="334155"/>
                 </a:solidFill>
@@ -25386,7 +25716,7 @@
               <a:t>rigido</a:t>
             </a:r>
             <a:r>
-              <a:rPr lang="en-US" sz="850">
+              <a:rPr lang="en-US" sz="850" dirty="0">
                 <a:solidFill>
                   <a:srgbClr val="334155"/>
                 </a:solidFill>
@@ -25397,7 +25727,7 @@
               <a:t> (hard clustering), ma </a:t>
             </a:r>
             <a:r>
-              <a:rPr lang="en-US" sz="850" err="1">
+              <a:rPr lang="en-US" sz="850" dirty="0" err="1">
                 <a:solidFill>
                   <a:srgbClr val="334155"/>
                 </a:solidFill>
@@ -25408,7 +25738,7 @@
               <a:t>calcola</a:t>
             </a:r>
             <a:r>
-              <a:rPr lang="en-US" sz="850">
+              <a:rPr lang="en-US" sz="850" dirty="0">
                 <a:solidFill>
                   <a:srgbClr val="334155"/>
                 </a:solidFill>
@@ -25419,7 +25749,7 @@
               <a:t> </a:t>
             </a:r>
             <a:r>
-              <a:rPr lang="en-US" sz="850" err="1">
+              <a:rPr lang="en-US" sz="850" dirty="0" err="1">
                 <a:solidFill>
                   <a:srgbClr val="334155"/>
                 </a:solidFill>
@@ -25430,7 +25760,7 @@
               <a:t>gradi</a:t>
             </a:r>
             <a:r>
-              <a:rPr lang="en-US" sz="850">
+              <a:rPr lang="en-US" sz="850" dirty="0">
                 <a:solidFill>
                   <a:srgbClr val="334155"/>
                 </a:solidFill>
@@ -25441,7 +25771,7 @@
               <a:t> </a:t>
             </a:r>
             <a:r>
-              <a:rPr lang="en-US" sz="850" err="1">
+              <a:rPr lang="en-US" sz="850" dirty="0" err="1">
                 <a:solidFill>
                   <a:srgbClr val="334155"/>
                 </a:solidFill>
@@ -25452,7 +25782,7 @@
               <a:t>continui</a:t>
             </a:r>
             <a:r>
-              <a:rPr lang="en-US" sz="850">
+              <a:rPr lang="en-US" sz="850" dirty="0">
                 <a:solidFill>
                   <a:srgbClr val="334155"/>
                 </a:solidFill>
@@ -25463,7 +25793,7 @@
               <a:t> di </a:t>
             </a:r>
             <a:r>
-              <a:rPr lang="en-US" sz="850" err="1">
+              <a:rPr lang="en-US" sz="850" dirty="0" err="1">
                 <a:solidFill>
                   <a:srgbClr val="334155"/>
                 </a:solidFill>
@@ -25474,18 +25804,40 @@
               <a:t>appartenenza</a:t>
             </a:r>
             <a:r>
-              <a:rPr lang="en-US" sz="850">
-                <a:solidFill>
-                  <a:srgbClr val="334155"/>
-                </a:solidFill>
-                <a:latin typeface="Arial"/>
-                <a:ea typeface="Arial" pitchFamily="34" charset="-122"/>
-                <a:cs typeface="Arial"/>
-              </a:rPr>
-              <a:t> (membership). Modella </a:t>
-            </a:r>
-            <a:r>
-              <a:rPr lang="en-US" sz="850" err="1">
+              <a:rPr lang="en-US" sz="850" dirty="0">
+                <a:solidFill>
+                  <a:srgbClr val="334155"/>
+                </a:solidFill>
+                <a:latin typeface="Arial"/>
+                <a:ea typeface="Arial" pitchFamily="34" charset="-122"/>
+                <a:cs typeface="Arial"/>
+              </a:rPr>
+              <a:t> (membership) per </a:t>
+            </a:r>
+            <a:r>
+              <a:rPr lang="en-US" sz="850" dirty="0" err="1">
+                <a:solidFill>
+                  <a:srgbClr val="334155"/>
+                </a:solidFill>
+                <a:latin typeface="Arial"/>
+                <a:ea typeface="Arial" pitchFamily="34" charset="-122"/>
+                <a:cs typeface="Arial"/>
+              </a:rPr>
+              <a:t>i</a:t>
+            </a:r>
+            <a:r>
+              <a:rPr lang="en-US" sz="850" dirty="0">
+                <a:solidFill>
+                  <a:srgbClr val="334155"/>
+                </a:solidFill>
+                <a:latin typeface="Arial"/>
+                <a:ea typeface="Arial" pitchFamily="34" charset="-122"/>
+                <a:cs typeface="Arial"/>
+              </a:rPr>
+              <a:t> k cluster. Modella </a:t>
+            </a:r>
+            <a:r>
+              <a:rPr lang="en-US" sz="850" dirty="0" err="1">
                 <a:solidFill>
                   <a:srgbClr val="334155"/>
                 </a:solidFill>
@@ -25496,7 +25848,7 @@
               <a:t>perfettamente</a:t>
             </a:r>
             <a:r>
-              <a:rPr lang="en-US" sz="850">
+              <a:rPr lang="en-US" sz="850" dirty="0">
                 <a:solidFill>
                   <a:srgbClr val="334155"/>
                 </a:solidFill>
@@ -25507,7 +25859,7 @@
               <a:t> </a:t>
             </a:r>
             <a:r>
-              <a:rPr lang="en-US" sz="850" err="1">
+              <a:rPr lang="en-US" sz="850" dirty="0" err="1">
                 <a:solidFill>
                   <a:srgbClr val="334155"/>
                 </a:solidFill>
@@ -25518,17 +25870,83 @@
               <a:t>l'imprecisione</a:t>
             </a:r>
             <a:r>
-              <a:rPr lang="en-US" sz="850">
-                <a:solidFill>
-                  <a:srgbClr val="334155"/>
-                </a:solidFill>
-                <a:latin typeface="Arial"/>
-                <a:ea typeface="Arial" pitchFamily="34" charset="-122"/>
-                <a:cs typeface="Arial"/>
-              </a:rPr>
-              <a:t> iniziale dei requisiti.</a:t>
-            </a:r>
-            <a:endParaRPr lang="en-US" sz="850">
+              <a:rPr lang="en-US" sz="850" dirty="0">
+                <a:solidFill>
+                  <a:srgbClr val="334155"/>
+                </a:solidFill>
+                <a:latin typeface="Arial"/>
+                <a:ea typeface="Arial" pitchFamily="34" charset="-122"/>
+                <a:cs typeface="Arial"/>
+              </a:rPr>
+              <a:t> </a:t>
+            </a:r>
+            <a:r>
+              <a:rPr lang="en-US" sz="850" dirty="0" err="1">
+                <a:solidFill>
+                  <a:srgbClr val="334155"/>
+                </a:solidFill>
+                <a:latin typeface="Arial"/>
+                <a:ea typeface="Arial" pitchFamily="34" charset="-122"/>
+                <a:cs typeface="Arial"/>
+              </a:rPr>
+              <a:t>iniziale</a:t>
+            </a:r>
+            <a:r>
+              <a:rPr lang="en-US" sz="850" dirty="0">
+                <a:solidFill>
+                  <a:srgbClr val="334155"/>
+                </a:solidFill>
+                <a:latin typeface="Arial"/>
+                <a:ea typeface="Arial" pitchFamily="34" charset="-122"/>
+                <a:cs typeface="Arial"/>
+              </a:rPr>
+              <a:t> </a:t>
+            </a:r>
+            <a:r>
+              <a:rPr lang="en-US" sz="850" dirty="0" err="1">
+                <a:solidFill>
+                  <a:srgbClr val="334155"/>
+                </a:solidFill>
+                <a:latin typeface="Arial"/>
+                <a:ea typeface="Arial" pitchFamily="34" charset="-122"/>
+                <a:cs typeface="Arial"/>
+              </a:rPr>
+              <a:t>dei</a:t>
+            </a:r>
+            <a:r>
+              <a:rPr lang="en-US" sz="850" dirty="0">
+                <a:solidFill>
+                  <a:srgbClr val="334155"/>
+                </a:solidFill>
+                <a:latin typeface="Arial"/>
+                <a:ea typeface="Arial" pitchFamily="34" charset="-122"/>
+                <a:cs typeface="Arial"/>
+              </a:rPr>
+              <a:t> </a:t>
+            </a:r>
+            <a:r>
+              <a:rPr lang="en-US" sz="850" dirty="0" err="1">
+                <a:solidFill>
+                  <a:srgbClr val="334155"/>
+                </a:solidFill>
+                <a:latin typeface="Arial"/>
+                <a:ea typeface="Arial" pitchFamily="34" charset="-122"/>
+                <a:cs typeface="Arial"/>
+              </a:rPr>
+              <a:t>requisiti</a:t>
+            </a:r>
+            <a:r>
+              <a:rPr lang="en-US" sz="850" dirty="0">
+                <a:solidFill>
+                  <a:srgbClr val="334155"/>
+                </a:solidFill>
+                <a:latin typeface="Arial"/>
+                <a:ea typeface="Arial" pitchFamily="34" charset="-122"/>
+                <a:cs typeface="Arial"/>
+              </a:rPr>
+              <a:t>.</a:t>
+            </a:r>
+            <a:endParaRPr lang="en-US" sz="850" dirty="0">
               <a:latin typeface="Arial"/>
               <a:cs typeface="Arial"/>
             </a:endParaRPr>
@@ -25675,17 +26093,358 @@
               <a:buNone/>
             </a:pPr>
             <a:r>
-              <a:rPr lang="en-US" sz="850">
-                <a:solidFill>
-                  <a:srgbClr val="334155"/>
-                </a:solidFill>
-                <a:latin typeface="Arial" pitchFamily="34" charset="0"/>
-                <a:ea typeface="Arial" pitchFamily="34" charset="-122"/>
-                <a:cs typeface="Arial" pitchFamily="34" charset="-120"/>
-              </a:rPr>
-              <a:t>Trasformando il vettore 1D in matrice 2D fuzzy, una Conv2D scansiona le interazioni incrociate tra attributi (es. Input vs File) estraendo pattern locali invisibili a formule o SVM.</a:t>
-            </a:r>
-            <a:endParaRPr lang="en-US" sz="850"/>
+              <a:rPr lang="en-US" sz="850" dirty="0" err="1">
+                <a:solidFill>
+                  <a:srgbClr val="334155"/>
+                </a:solidFill>
+                <a:latin typeface="Arial" pitchFamily="34" charset="0"/>
+                <a:ea typeface="Arial" pitchFamily="34" charset="-122"/>
+                <a:cs typeface="Arial" pitchFamily="34" charset="-120"/>
+              </a:rPr>
+              <a:t>Trasformando</a:t>
+            </a:r>
+            <a:r>
+              <a:rPr lang="en-US" sz="850" dirty="0">
+                <a:solidFill>
+                  <a:srgbClr val="334155"/>
+                </a:solidFill>
+                <a:latin typeface="Arial" pitchFamily="34" charset="0"/>
+                <a:ea typeface="Arial" pitchFamily="34" charset="-122"/>
+                <a:cs typeface="Arial" pitchFamily="34" charset="-120"/>
+              </a:rPr>
+              <a:t> il </a:t>
+            </a:r>
+            <a:r>
+              <a:rPr lang="en-US" sz="850" dirty="0" err="1">
+                <a:solidFill>
+                  <a:srgbClr val="334155"/>
+                </a:solidFill>
+                <a:latin typeface="Arial" pitchFamily="34" charset="0"/>
+                <a:ea typeface="Arial" pitchFamily="34" charset="-122"/>
+                <a:cs typeface="Arial" pitchFamily="34" charset="-120"/>
+              </a:rPr>
+              <a:t>vettore</a:t>
+            </a:r>
+            <a:r>
+              <a:rPr lang="en-US" sz="850" dirty="0">
+                <a:solidFill>
+                  <a:srgbClr val="334155"/>
+                </a:solidFill>
+                <a:latin typeface="Arial" pitchFamily="34" charset="0"/>
+                <a:ea typeface="Arial" pitchFamily="34" charset="-122"/>
+                <a:cs typeface="Arial" pitchFamily="34" charset="-120"/>
+              </a:rPr>
+              <a:t> 1D in </a:t>
+            </a:r>
+            <a:r>
+              <a:rPr lang="en-US" sz="850" dirty="0" err="1">
+                <a:solidFill>
+                  <a:srgbClr val="334155"/>
+                </a:solidFill>
+                <a:latin typeface="Arial" pitchFamily="34" charset="0"/>
+                <a:ea typeface="Arial" pitchFamily="34" charset="-122"/>
+                <a:cs typeface="Arial" pitchFamily="34" charset="-120"/>
+              </a:rPr>
+              <a:t>matrice</a:t>
+            </a:r>
+            <a:r>
+              <a:rPr lang="en-US" sz="850" dirty="0">
+                <a:solidFill>
+                  <a:srgbClr val="334155"/>
+                </a:solidFill>
+                <a:latin typeface="Arial" pitchFamily="34" charset="0"/>
+                <a:ea typeface="Arial" pitchFamily="34" charset="-122"/>
+                <a:cs typeface="Arial" pitchFamily="34" charset="-120"/>
+              </a:rPr>
+              <a:t> 2D fuzzy, </a:t>
+            </a:r>
+            <a:r>
+              <a:rPr lang="en-US" sz="850" dirty="0" err="1">
+                <a:solidFill>
+                  <a:srgbClr val="334155"/>
+                </a:solidFill>
+                <a:latin typeface="Arial" pitchFamily="34" charset="0"/>
+                <a:ea typeface="Arial" pitchFamily="34" charset="-122"/>
+                <a:cs typeface="Arial" pitchFamily="34" charset="-120"/>
+              </a:rPr>
+              <a:t>una</a:t>
+            </a:r>
+            <a:r>
+              <a:rPr lang="en-US" sz="850" dirty="0">
+                <a:solidFill>
+                  <a:srgbClr val="334155"/>
+                </a:solidFill>
+                <a:latin typeface="Arial" pitchFamily="34" charset="0"/>
+                <a:ea typeface="Arial" pitchFamily="34" charset="-122"/>
+                <a:cs typeface="Arial" pitchFamily="34" charset="-120"/>
+              </a:rPr>
+              <a:t> Conv2D (feature </a:t>
+            </a:r>
+            <a:r>
+              <a:rPr lang="en-US" sz="850" dirty="0" err="1">
+                <a:solidFill>
+                  <a:srgbClr val="334155"/>
+                </a:solidFill>
+                <a:latin typeface="Arial" pitchFamily="34" charset="0"/>
+                <a:ea typeface="Arial" pitchFamily="34" charset="-122"/>
+                <a:cs typeface="Arial" pitchFamily="34" charset="-120"/>
+              </a:rPr>
+              <a:t>funzionali</a:t>
+            </a:r>
+            <a:r>
+              <a:rPr lang="en-US" sz="850" dirty="0">
+                <a:solidFill>
+                  <a:srgbClr val="334155"/>
+                </a:solidFill>
+                <a:latin typeface="Arial" pitchFamily="34" charset="0"/>
+                <a:ea typeface="Arial" pitchFamily="34" charset="-122"/>
+                <a:cs typeface="Arial" pitchFamily="34" charset="-120"/>
+              </a:rPr>
+              <a:t> x </a:t>
+            </a:r>
+            <a:r>
+              <a:rPr lang="en-US" sz="850" dirty="0" err="1">
+                <a:solidFill>
+                  <a:srgbClr val="334155"/>
+                </a:solidFill>
+                <a:latin typeface="Arial" pitchFamily="34" charset="0"/>
+                <a:ea typeface="Arial" pitchFamily="34" charset="-122"/>
+                <a:cs typeface="Arial" pitchFamily="34" charset="-120"/>
+              </a:rPr>
+              <a:t>grado</a:t>
+            </a:r>
+            <a:r>
+              <a:rPr lang="en-US" sz="850" dirty="0">
+                <a:solidFill>
+                  <a:srgbClr val="334155"/>
+                </a:solidFill>
+                <a:latin typeface="Arial" pitchFamily="34" charset="0"/>
+                <a:ea typeface="Arial" pitchFamily="34" charset="-122"/>
+                <a:cs typeface="Arial" pitchFamily="34" charset="-120"/>
+              </a:rPr>
+              <a:t> di </a:t>
+            </a:r>
+            <a:r>
+              <a:rPr lang="en-US" sz="850" dirty="0" err="1">
+                <a:solidFill>
+                  <a:srgbClr val="334155"/>
+                </a:solidFill>
+                <a:latin typeface="Arial" pitchFamily="34" charset="0"/>
+                <a:ea typeface="Arial" pitchFamily="34" charset="-122"/>
+                <a:cs typeface="Arial" pitchFamily="34" charset="-120"/>
+              </a:rPr>
+              <a:t>appartenenza</a:t>
+            </a:r>
+            <a:r>
+              <a:rPr lang="en-US" sz="850" dirty="0">
+                <a:solidFill>
+                  <a:srgbClr val="334155"/>
+                </a:solidFill>
+                <a:latin typeface="Arial" pitchFamily="34" charset="0"/>
+                <a:ea typeface="Arial" pitchFamily="34" charset="-122"/>
+                <a:cs typeface="Arial" pitchFamily="34" charset="-120"/>
+              </a:rPr>
+              <a:t>) </a:t>
+            </a:r>
+            <a:r>
+              <a:rPr lang="en-US" sz="850" dirty="0" err="1">
+                <a:solidFill>
+                  <a:srgbClr val="334155"/>
+                </a:solidFill>
+                <a:latin typeface="Arial" pitchFamily="34" charset="0"/>
+                <a:ea typeface="Arial" pitchFamily="34" charset="-122"/>
+                <a:cs typeface="Arial" pitchFamily="34" charset="-120"/>
+              </a:rPr>
+              <a:t>scansiona</a:t>
+            </a:r>
+            <a:r>
+              <a:rPr lang="en-US" sz="850" dirty="0">
+                <a:solidFill>
+                  <a:srgbClr val="334155"/>
+                </a:solidFill>
+                <a:latin typeface="Arial" pitchFamily="34" charset="0"/>
+                <a:ea typeface="Arial" pitchFamily="34" charset="-122"/>
+                <a:cs typeface="Arial" pitchFamily="34" charset="-120"/>
+              </a:rPr>
+              <a:t> le </a:t>
+            </a:r>
+            <a:r>
+              <a:rPr lang="en-US" sz="850" dirty="0" err="1">
+                <a:solidFill>
+                  <a:srgbClr val="334155"/>
+                </a:solidFill>
+                <a:latin typeface="Arial" pitchFamily="34" charset="0"/>
+                <a:ea typeface="Arial" pitchFamily="34" charset="-122"/>
+                <a:cs typeface="Arial" pitchFamily="34" charset="-120"/>
+              </a:rPr>
+              <a:t>interazioni</a:t>
+            </a:r>
+            <a:r>
+              <a:rPr lang="en-US" sz="850" dirty="0">
+                <a:solidFill>
+                  <a:srgbClr val="334155"/>
+                </a:solidFill>
+                <a:latin typeface="Arial" pitchFamily="34" charset="0"/>
+                <a:ea typeface="Arial" pitchFamily="34" charset="-122"/>
+                <a:cs typeface="Arial" pitchFamily="34" charset="-120"/>
+              </a:rPr>
+              <a:t> </a:t>
+            </a:r>
+            <a:r>
+              <a:rPr lang="en-US" sz="850" dirty="0" err="1">
+                <a:solidFill>
+                  <a:srgbClr val="334155"/>
+                </a:solidFill>
+                <a:latin typeface="Arial" pitchFamily="34" charset="0"/>
+                <a:ea typeface="Arial" pitchFamily="34" charset="-122"/>
+                <a:cs typeface="Arial" pitchFamily="34" charset="-120"/>
+              </a:rPr>
+              <a:t>incrociate</a:t>
+            </a:r>
+            <a:r>
+              <a:rPr lang="en-US" sz="850" dirty="0">
+                <a:solidFill>
+                  <a:srgbClr val="334155"/>
+                </a:solidFill>
+                <a:latin typeface="Arial" pitchFamily="34" charset="0"/>
+                <a:ea typeface="Arial" pitchFamily="34" charset="-122"/>
+                <a:cs typeface="Arial" pitchFamily="34" charset="-120"/>
+              </a:rPr>
+              <a:t> </a:t>
+            </a:r>
+            <a:r>
+              <a:rPr lang="en-US" sz="850" dirty="0" err="1">
+                <a:solidFill>
+                  <a:srgbClr val="334155"/>
+                </a:solidFill>
+                <a:latin typeface="Arial" pitchFamily="34" charset="0"/>
+                <a:ea typeface="Arial" pitchFamily="34" charset="-122"/>
+                <a:cs typeface="Arial" pitchFamily="34" charset="-120"/>
+              </a:rPr>
+              <a:t>tra</a:t>
+            </a:r>
+            <a:r>
+              <a:rPr lang="en-US" sz="850" dirty="0">
+                <a:solidFill>
+                  <a:srgbClr val="334155"/>
+                </a:solidFill>
+                <a:latin typeface="Arial" pitchFamily="34" charset="0"/>
+                <a:ea typeface="Arial" pitchFamily="34" charset="-122"/>
+                <a:cs typeface="Arial" pitchFamily="34" charset="-120"/>
+              </a:rPr>
+              <a:t> </a:t>
+            </a:r>
+            <a:r>
+              <a:rPr lang="en-US" sz="850" dirty="0" err="1">
+                <a:solidFill>
+                  <a:srgbClr val="334155"/>
+                </a:solidFill>
+                <a:latin typeface="Arial" pitchFamily="34" charset="0"/>
+                <a:ea typeface="Arial" pitchFamily="34" charset="-122"/>
+                <a:cs typeface="Arial" pitchFamily="34" charset="-120"/>
+              </a:rPr>
+              <a:t>attributi</a:t>
+            </a:r>
+            <a:r>
+              <a:rPr lang="en-US" sz="850" dirty="0">
+                <a:solidFill>
+                  <a:srgbClr val="334155"/>
+                </a:solidFill>
+                <a:latin typeface="Arial" pitchFamily="34" charset="0"/>
+                <a:ea typeface="Arial" pitchFamily="34" charset="-122"/>
+                <a:cs typeface="Arial" pitchFamily="34" charset="-120"/>
+              </a:rPr>
+              <a:t> (es. Input vs File) </a:t>
+            </a:r>
+            <a:r>
+              <a:rPr lang="en-US" sz="850" dirty="0" err="1">
+                <a:solidFill>
+                  <a:srgbClr val="334155"/>
+                </a:solidFill>
+                <a:latin typeface="Arial" pitchFamily="34" charset="0"/>
+                <a:ea typeface="Arial" pitchFamily="34" charset="-122"/>
+                <a:cs typeface="Arial" pitchFamily="34" charset="-120"/>
+              </a:rPr>
+              <a:t>estraendo</a:t>
+            </a:r>
+            <a:r>
+              <a:rPr lang="en-US" sz="850" dirty="0">
+                <a:solidFill>
+                  <a:srgbClr val="334155"/>
+                </a:solidFill>
+                <a:latin typeface="Arial" pitchFamily="34" charset="0"/>
+                <a:ea typeface="Arial" pitchFamily="34" charset="-122"/>
+                <a:cs typeface="Arial" pitchFamily="34" charset="-120"/>
+              </a:rPr>
+              <a:t> pattern </a:t>
+            </a:r>
+            <a:r>
+              <a:rPr lang="en-US" sz="850" dirty="0" err="1">
+                <a:solidFill>
+                  <a:srgbClr val="334155"/>
+                </a:solidFill>
+                <a:latin typeface="Arial" pitchFamily="34" charset="0"/>
+                <a:ea typeface="Arial" pitchFamily="34" charset="-122"/>
+                <a:cs typeface="Arial" pitchFamily="34" charset="-120"/>
+              </a:rPr>
+              <a:t>locali</a:t>
+            </a:r>
+            <a:r>
+              <a:rPr lang="en-US" sz="850" dirty="0">
+                <a:solidFill>
+                  <a:srgbClr val="334155"/>
+                </a:solidFill>
+                <a:latin typeface="Arial" pitchFamily="34" charset="0"/>
+                <a:ea typeface="Arial" pitchFamily="34" charset="-122"/>
+                <a:cs typeface="Arial" pitchFamily="34" charset="-120"/>
+              </a:rPr>
+              <a:t> </a:t>
+            </a:r>
+            <a:r>
+              <a:rPr lang="en-US" sz="850" dirty="0" err="1">
+                <a:solidFill>
+                  <a:srgbClr val="334155"/>
+                </a:solidFill>
+                <a:latin typeface="Arial" pitchFamily="34" charset="0"/>
+                <a:ea typeface="Arial" pitchFamily="34" charset="-122"/>
+                <a:cs typeface="Arial" pitchFamily="34" charset="-120"/>
+              </a:rPr>
+              <a:t>invisibili</a:t>
+            </a:r>
+            <a:r>
+              <a:rPr lang="en-US" sz="850" dirty="0">
+                <a:solidFill>
+                  <a:srgbClr val="334155"/>
+                </a:solidFill>
+                <a:latin typeface="Arial" pitchFamily="34" charset="0"/>
+                <a:ea typeface="Arial" pitchFamily="34" charset="-122"/>
+                <a:cs typeface="Arial" pitchFamily="34" charset="-120"/>
+              </a:rPr>
+              <a:t> a </a:t>
+            </a:r>
+            <a:r>
+              <a:rPr lang="en-US" sz="850" dirty="0" err="1">
+                <a:solidFill>
+                  <a:srgbClr val="334155"/>
+                </a:solidFill>
+                <a:latin typeface="Arial" pitchFamily="34" charset="0"/>
+                <a:ea typeface="Arial" pitchFamily="34" charset="-122"/>
+                <a:cs typeface="Arial" pitchFamily="34" charset="-120"/>
+              </a:rPr>
+              <a:t>formule</a:t>
+            </a:r>
+            <a:r>
+              <a:rPr lang="en-US" sz="850" dirty="0">
+                <a:solidFill>
+                  <a:srgbClr val="334155"/>
+                </a:solidFill>
+                <a:latin typeface="Arial" pitchFamily="34" charset="0"/>
+                <a:ea typeface="Arial" pitchFamily="34" charset="-122"/>
+                <a:cs typeface="Arial" pitchFamily="34" charset="-120"/>
+              </a:rPr>
+              <a:t> o SVM.</a:t>
+            </a:r>
+            <a:endParaRPr lang="en-US" sz="850" dirty="0"/>
           </a:p>
         </p:txBody>
       </p:sp>
@@ -25857,11 +26616,11 @@
           <a:p>
             <a:pPr>
               <a:lnSpc>
-                <a:spcPts val="1200"/>
+                <a:spcPct val="100000"/>
               </a:lnSpc>
             </a:pPr>
             <a:r>
-              <a:rPr lang="en-US" sz="850" err="1">
+              <a:rPr lang="en-US" sz="850" dirty="0" err="1">
                 <a:solidFill>
                   <a:srgbClr val="334155"/>
                 </a:solidFill>
@@ -25872,7 +26631,7 @@
               <a:t>Pochissimi</a:t>
             </a:r>
             <a:r>
-              <a:rPr lang="en-US" sz="850">
+              <a:rPr lang="en-US" sz="850" dirty="0">
                 <a:solidFill>
                   <a:srgbClr val="334155"/>
                 </a:solidFill>
@@ -25883,7 +26642,7 @@
               <a:t> </a:t>
             </a:r>
             <a:r>
-              <a:rPr lang="en-US" sz="850" err="1">
+              <a:rPr lang="en-US" sz="850" dirty="0" err="1">
                 <a:solidFill>
                   <a:srgbClr val="334155"/>
                 </a:solidFill>
@@ -25894,7 +26653,7 @@
               <a:t>parametri</a:t>
             </a:r>
             <a:r>
-              <a:rPr lang="en-US" sz="850">
+              <a:rPr lang="en-US" sz="850" dirty="0">
                 <a:solidFill>
                   <a:srgbClr val="334155"/>
                 </a:solidFill>
@@ -25905,7 +26664,7 @@
               <a:t> rispetto a </a:t>
             </a:r>
             <a:r>
-              <a:rPr lang="en-US" sz="850" err="1">
+              <a:rPr lang="en-US" sz="850" dirty="0" err="1">
                 <a:solidFill>
                   <a:srgbClr val="334155"/>
                 </a:solidFill>
@@ -25916,7 +26675,7 @@
               <a:t>modelli</a:t>
             </a:r>
             <a:r>
-              <a:rPr lang="en-US" sz="850">
+              <a:rPr lang="en-US" sz="850" dirty="0">
                 <a:solidFill>
                   <a:srgbClr val="334155"/>
                 </a:solidFill>
@@ -25927,7 +26686,7 @@
               <a:t> </a:t>
             </a:r>
             <a:r>
-              <a:rPr lang="en-US" sz="850" err="1">
+              <a:rPr lang="en-US" sz="850" dirty="0" err="1">
                 <a:solidFill>
                   <a:srgbClr val="334155"/>
                 </a:solidFill>
@@ -25938,7 +26697,7 @@
               <a:t>più</a:t>
             </a:r>
             <a:r>
-              <a:rPr lang="en-US" sz="850">
+              <a:rPr lang="en-US" sz="850" dirty="0">
                 <a:solidFill>
                   <a:srgbClr val="334155"/>
                 </a:solidFill>
@@ -25949,7 +26708,7 @@
               <a:t> </a:t>
             </a:r>
             <a:r>
-              <a:rPr lang="en-US" sz="850" err="1">
+              <a:rPr lang="en-US" sz="850" dirty="0" err="1">
                 <a:solidFill>
                   <a:srgbClr val="334155"/>
                 </a:solidFill>
@@ -25960,7 +26719,7 @@
               <a:t>complessi</a:t>
             </a:r>
             <a:r>
-              <a:rPr lang="en-US" sz="850">
+              <a:rPr lang="en-US" sz="850" dirty="0">
                 <a:solidFill>
                   <a:srgbClr val="334155"/>
                 </a:solidFill>
@@ -25971,7 +26730,7 @@
               <a:t> (come </a:t>
             </a:r>
             <a:r>
-              <a:rPr lang="en-US" sz="850" err="1">
+              <a:rPr lang="en-US" sz="850" dirty="0" err="1">
                 <a:solidFill>
                   <a:srgbClr val="334155"/>
                 </a:solidFill>
@@ -25982,18 +26741,84 @@
               <a:t>TabNet+HHO</a:t>
             </a:r>
             <a:r>
-              <a:rPr lang="en-US" sz="850">
-                <a:solidFill>
-                  <a:srgbClr val="334155"/>
-                </a:solidFill>
-                <a:latin typeface="Arial"/>
-                <a:ea typeface="Arial" pitchFamily="34" charset="-122"/>
-                <a:cs typeface="Arial"/>
-              </a:rPr>
-              <a:t> o Ensembles da ore di </a:t>
-            </a:r>
-            <a:r>
-              <a:rPr lang="en-US" sz="850" err="1">
+              <a:rPr lang="en-US" sz="850" dirty="0">
+                <a:solidFill>
+                  <a:srgbClr val="334155"/>
+                </a:solidFill>
+                <a:latin typeface="Arial"/>
+                <a:ea typeface="Arial" pitchFamily="34" charset="-122"/>
+                <a:cs typeface="Arial"/>
+              </a:rPr>
+              <a:t> o Ensembles, </a:t>
+            </a:r>
+            <a:r>
+              <a:rPr lang="en-US" sz="850" dirty="0" err="1">
+                <a:solidFill>
+                  <a:srgbClr val="334155"/>
+                </a:solidFill>
+                <a:latin typeface="Arial"/>
+                <a:ea typeface="Arial" pitchFamily="34" charset="-122"/>
+                <a:cs typeface="Arial"/>
+              </a:rPr>
+              <a:t>reti</a:t>
+            </a:r>
+            <a:r>
+              <a:rPr lang="en-US" sz="850" dirty="0">
+                <a:solidFill>
+                  <a:srgbClr val="334155"/>
+                </a:solidFill>
+                <a:latin typeface="Arial"/>
+                <a:ea typeface="Arial" pitchFamily="34" charset="-122"/>
+                <a:cs typeface="Arial"/>
+              </a:rPr>
+              <a:t> </a:t>
+            </a:r>
+            <a:r>
+              <a:rPr lang="en-US" sz="850" dirty="0" err="1">
+                <a:solidFill>
+                  <a:srgbClr val="334155"/>
+                </a:solidFill>
+                <a:latin typeface="Arial"/>
+                <a:ea typeface="Arial" pitchFamily="34" charset="-122"/>
+                <a:cs typeface="Arial"/>
+              </a:rPr>
+              <a:t>tabulari</a:t>
+            </a:r>
+            <a:r>
+              <a:rPr lang="en-US" sz="850" dirty="0">
+                <a:solidFill>
+                  <a:srgbClr val="334155"/>
+                </a:solidFill>
+                <a:latin typeface="Arial"/>
+                <a:ea typeface="Arial" pitchFamily="34" charset="-122"/>
+                <a:cs typeface="Arial"/>
+              </a:rPr>
+              <a:t> ad </a:t>
+            </a:r>
+            <a:r>
+              <a:rPr lang="en-US" sz="850" dirty="0" err="1">
+                <a:solidFill>
+                  <a:srgbClr val="334155"/>
+                </a:solidFill>
+                <a:latin typeface="Arial"/>
+                <a:ea typeface="Arial" pitchFamily="34" charset="-122"/>
+                <a:cs typeface="Arial"/>
+              </a:rPr>
+              <a:t>attenzione</a:t>
+            </a:r>
+            <a:r>
+              <a:rPr lang="en-US" sz="850" dirty="0">
+                <a:solidFill>
+                  <a:srgbClr val="334155"/>
+                </a:solidFill>
+                <a:latin typeface="Arial"/>
+                <a:ea typeface="Arial" pitchFamily="34" charset="-122"/>
+                <a:cs typeface="Arial"/>
+              </a:rPr>
+              <a:t>, da ore di </a:t>
+            </a:r>
+            <a:r>
+              <a:rPr lang="en-US" sz="850" dirty="0" err="1">
                 <a:solidFill>
                   <a:srgbClr val="334155"/>
                 </a:solidFill>
@@ -26004,7 +26829,7 @@
               <a:t>addestramento</a:t>
             </a:r>
             <a:r>
-              <a:rPr lang="en-US" sz="850">
+              <a:rPr lang="en-US" sz="850" dirty="0">
                 <a:solidFill>
                   <a:srgbClr val="334155"/>
                 </a:solidFill>
@@ -26014,7 +26839,7 @@
               </a:rPr>
               <a:t> e alto overfitting). </a:t>
             </a:r>
-            <a:endParaRPr lang="en-US" sz="850">
+            <a:endParaRPr lang="en-US" sz="850" dirty="0">
               <a:latin typeface="Arial"/>
               <a:cs typeface="Arial"/>
             </a:endParaRPr>

</xml_diff>